<commit_message>
Finished exercises tab design
</commit_message>
<xml_diff>
--- a/03-Diseno/Wireframe/Wireframe.pptx
+++ b/03-Diseno/Wireframe/Wireframe.pptx
@@ -126,7 +126,7 @@
 <file path=ppt/revisionInfo.xml><?xml version="1.0" encoding="utf-8"?>
 <p1510:revInfo xmlns:a="http://schemas.openxmlformats.org/drawingml/2006/main" xmlns:r="http://schemas.openxmlformats.org/officeDocument/2006/relationships" xmlns:p1510="http://schemas.microsoft.com/office/powerpoint/2015/10/main">
   <p1510:revLst>
-    <p1510:client id="{4BDD1575-694C-44DC-A5EA-6A642F0D5B4A}" v="264" dt="2025-01-25T21:05:52.454"/>
+    <p1510:client id="{4BDD1575-694C-44DC-A5EA-6A642F0D5B4A}" v="383" dt="2025-01-26T03:07:17.910"/>
   </p1510:revLst>
 </p1510:revInfo>
 </file>
@@ -136,7 +136,7 @@
   <pc:docChgLst>
     <pc:chgData name="Joul Espinoza" userId="8b4f8c1dfa2d7319" providerId="LiveId" clId="{4BDD1575-694C-44DC-A5EA-6A642F0D5B4A}"/>
     <pc:docChg chg="undo custSel addSld delSld modSld">
-      <pc:chgData name="Joul Espinoza" userId="8b4f8c1dfa2d7319" providerId="LiveId" clId="{4BDD1575-694C-44DC-A5EA-6A642F0D5B4A}" dt="2025-01-25T21:06:09.094" v="1536" actId="122"/>
+      <pc:chgData name="Joul Espinoza" userId="8b4f8c1dfa2d7319" providerId="LiveId" clId="{4BDD1575-694C-44DC-A5EA-6A642F0D5B4A}" dt="2025-01-26T03:07:49.046" v="2182" actId="1076"/>
       <pc:docMkLst>
         <pc:docMk/>
       </pc:docMkLst>
@@ -148,7 +148,7 @@
         </pc:sldMkLst>
       </pc:sldChg>
       <pc:sldChg chg="addSp delSp modSp new mod modClrScheme chgLayout">
-        <pc:chgData name="Joul Espinoza" userId="8b4f8c1dfa2d7319" providerId="LiveId" clId="{4BDD1575-694C-44DC-A5EA-6A642F0D5B4A}" dt="2025-01-25T21:06:09.094" v="1536" actId="122"/>
+        <pc:chgData name="Joul Espinoza" userId="8b4f8c1dfa2d7319" providerId="LiveId" clId="{4BDD1575-694C-44DC-A5EA-6A642F0D5B4A}" dt="2025-01-26T03:07:49.046" v="2182" actId="1076"/>
         <pc:sldMkLst>
           <pc:docMk/>
           <pc:sldMk cId="1763628168" sldId="257"/>
@@ -202,6 +202,14 @@
           </ac:spMkLst>
         </pc:spChg>
         <pc:spChg chg="add mod">
+          <ac:chgData name="Joul Espinoza" userId="8b4f8c1dfa2d7319" providerId="LiveId" clId="{4BDD1575-694C-44DC-A5EA-6A642F0D5B4A}" dt="2025-01-26T02:49:39.597" v="1552" actId="1035"/>
+          <ac:spMkLst>
+            <pc:docMk/>
+            <pc:sldMk cId="1763628168" sldId="257"/>
+            <ac:spMk id="6" creationId="{3C41C4FC-8876-3EBB-A993-2089976E4A1F}"/>
+          </ac:spMkLst>
+        </pc:spChg>
+        <pc:spChg chg="add mod">
           <ac:chgData name="Joul Espinoza" userId="8b4f8c1dfa2d7319" providerId="LiveId" clId="{4BDD1575-694C-44DC-A5EA-6A642F0D5B4A}" dt="2025-01-25T20:37:50.912" v="725" actId="1035"/>
           <ac:spMkLst>
             <pc:docMk/>
@@ -241,6 +249,14 @@
             <ac:spMk id="12" creationId="{00132079-F0D8-E23D-D971-8E188B90B9A0}"/>
           </ac:spMkLst>
         </pc:spChg>
+        <pc:spChg chg="add mod">
+          <ac:chgData name="Joul Espinoza" userId="8b4f8c1dfa2d7319" providerId="LiveId" clId="{4BDD1575-694C-44DC-A5EA-6A642F0D5B4A}" dt="2025-01-26T02:50:02.893" v="1569" actId="1035"/>
+          <ac:spMkLst>
+            <pc:docMk/>
+            <pc:sldMk cId="1763628168" sldId="257"/>
+            <ac:spMk id="12" creationId="{36838F62-F8D4-63BA-9CC6-5E059811246C}"/>
+          </ac:spMkLst>
+        </pc:spChg>
         <pc:spChg chg="add del mod">
           <ac:chgData name="Joul Espinoza" userId="8b4f8c1dfa2d7319" providerId="LiveId" clId="{4BDD1575-694C-44DC-A5EA-6A642F0D5B4A}" dt="2025-01-25T20:30:16.818" v="516" actId="478"/>
           <ac:spMkLst>
@@ -370,6 +386,30 @@
           </ac:spMkLst>
         </pc:spChg>
         <pc:spChg chg="add mod">
+          <ac:chgData name="Joul Espinoza" userId="8b4f8c1dfa2d7319" providerId="LiveId" clId="{4BDD1575-694C-44DC-A5EA-6A642F0D5B4A}" dt="2025-01-26T02:50:37.479" v="1590" actId="1035"/>
+          <ac:spMkLst>
+            <pc:docMk/>
+            <pc:sldMk cId="1763628168" sldId="257"/>
+            <ac:spMk id="36" creationId="{005FC1BB-DBE4-6242-3354-F6626A7A59C0}"/>
+          </ac:spMkLst>
+        </pc:spChg>
+        <pc:spChg chg="add del mod">
+          <ac:chgData name="Joul Espinoza" userId="8b4f8c1dfa2d7319" providerId="LiveId" clId="{4BDD1575-694C-44DC-A5EA-6A642F0D5B4A}" dt="2025-01-26T02:51:08.588" v="1595" actId="478"/>
+          <ac:spMkLst>
+            <pc:docMk/>
+            <pc:sldMk cId="1763628168" sldId="257"/>
+            <ac:spMk id="37" creationId="{752601DE-8DA6-3654-8343-A0435A359449}"/>
+          </ac:spMkLst>
+        </pc:spChg>
+        <pc:spChg chg="add mod">
+          <ac:chgData name="Joul Espinoza" userId="8b4f8c1dfa2d7319" providerId="LiveId" clId="{4BDD1575-694C-44DC-A5EA-6A642F0D5B4A}" dt="2025-01-26T02:51:45.328" v="1607" actId="403"/>
+          <ac:spMkLst>
+            <pc:docMk/>
+            <pc:sldMk cId="1763628168" sldId="257"/>
+            <ac:spMk id="38" creationId="{438E8FF0-9311-7871-44CC-F5E33C4FC3D3}"/>
+          </ac:spMkLst>
+        </pc:spChg>
+        <pc:spChg chg="add mod">
           <ac:chgData name="Joul Espinoza" userId="8b4f8c1dfa2d7319" providerId="LiveId" clId="{4BDD1575-694C-44DC-A5EA-6A642F0D5B4A}" dt="2025-01-25T20:41:22.991" v="902" actId="1076"/>
           <ac:spMkLst>
             <pc:docMk/>
@@ -562,11 +602,43 @@
           </ac:spMkLst>
         </pc:spChg>
         <pc:spChg chg="add mod">
+          <ac:chgData name="Joul Espinoza" userId="8b4f8c1dfa2d7319" providerId="LiveId" clId="{4BDD1575-694C-44DC-A5EA-6A642F0D5B4A}" dt="2025-01-26T02:53:26.156" v="1634" actId="20577"/>
+          <ac:spMkLst>
+            <pc:docMk/>
+            <pc:sldMk cId="1763628168" sldId="257"/>
+            <ac:spMk id="1054" creationId="{DDE4036C-96CF-13D1-7A7C-447AF206A8BB}"/>
+          </ac:spMkLst>
+        </pc:spChg>
+        <pc:spChg chg="add del mod">
+          <ac:chgData name="Joul Espinoza" userId="8b4f8c1dfa2d7319" providerId="LiveId" clId="{4BDD1575-694C-44DC-A5EA-6A642F0D5B4A}" dt="2025-01-26T02:53:45.683" v="1638" actId="478"/>
+          <ac:spMkLst>
+            <pc:docMk/>
+            <pc:sldMk cId="1763628168" sldId="257"/>
+            <ac:spMk id="1055" creationId="{E723058C-2424-23FF-5440-C80A35D0451C}"/>
+          </ac:spMkLst>
+        </pc:spChg>
+        <pc:spChg chg="add mod">
           <ac:chgData name="Joul Espinoza" userId="8b4f8c1dfa2d7319" providerId="LiveId" clId="{4BDD1575-694C-44DC-A5EA-6A642F0D5B4A}" dt="2025-01-25T20:56:08.362" v="1401" actId="1076"/>
           <ac:spMkLst>
             <pc:docMk/>
             <pc:sldMk cId="1763628168" sldId="257"/>
             <ac:spMk id="1056" creationId="{2F6ED685-7801-5F2C-7BE3-18300D2FF107}"/>
+          </ac:spMkLst>
+        </pc:spChg>
+        <pc:spChg chg="add mod">
+          <ac:chgData name="Joul Espinoza" userId="8b4f8c1dfa2d7319" providerId="LiveId" clId="{4BDD1575-694C-44DC-A5EA-6A642F0D5B4A}" dt="2025-01-26T02:54:47.059" v="1675" actId="20577"/>
+          <ac:spMkLst>
+            <pc:docMk/>
+            <pc:sldMk cId="1763628168" sldId="257"/>
+            <ac:spMk id="1057" creationId="{D803A238-D5C5-A9FF-EBAE-AA4CBF52F0B6}"/>
+          </ac:spMkLst>
+        </pc:spChg>
+        <pc:spChg chg="add mod">
+          <ac:chgData name="Joul Espinoza" userId="8b4f8c1dfa2d7319" providerId="LiveId" clId="{4BDD1575-694C-44DC-A5EA-6A642F0D5B4A}" dt="2025-01-26T02:54:43.405" v="1669" actId="404"/>
+          <ac:spMkLst>
+            <pc:docMk/>
+            <pc:sldMk cId="1763628168" sldId="257"/>
+            <ac:spMk id="1058" creationId="{349B4544-4D0E-4EB8-F4AD-5276FCB6BF51}"/>
           </ac:spMkLst>
         </pc:spChg>
         <pc:spChg chg="add mod">
@@ -577,12 +649,44 @@
             <ac:spMk id="1058" creationId="{A6412289-8B02-4BB7-35B3-BB476DC3FDAB}"/>
           </ac:spMkLst>
         </pc:spChg>
-        <pc:spChg chg="add mod">
-          <ac:chgData name="Joul Espinoza" userId="8b4f8c1dfa2d7319" providerId="LiveId" clId="{4BDD1575-694C-44DC-A5EA-6A642F0D5B4A}" dt="2025-01-25T20:59:37.961" v="1406" actId="1076"/>
+        <pc:spChg chg="add del">
+          <ac:chgData name="Joul Espinoza" userId="8b4f8c1dfa2d7319" providerId="LiveId" clId="{4BDD1575-694C-44DC-A5EA-6A642F0D5B4A}" dt="2025-01-26T02:58:00.355" v="1706" actId="478"/>
           <ac:spMkLst>
             <pc:docMk/>
             <pc:sldMk cId="1763628168" sldId="257"/>
-            <ac:spMk id="1066" creationId="{C57FA6F0-77D6-5FB2-9CA0-579C4AC5FACD}"/>
+            <ac:spMk id="1060" creationId="{BF1C6BF9-A256-C5B8-A396-DB60FF077E6A}"/>
+          </ac:spMkLst>
+        </pc:spChg>
+        <pc:spChg chg="add del">
+          <ac:chgData name="Joul Espinoza" userId="8b4f8c1dfa2d7319" providerId="LiveId" clId="{4BDD1575-694C-44DC-A5EA-6A642F0D5B4A}" dt="2025-01-26T02:58:07.986" v="1708" actId="478"/>
+          <ac:spMkLst>
+            <pc:docMk/>
+            <pc:sldMk cId="1763628168" sldId="257"/>
+            <ac:spMk id="1061" creationId="{B01ED05F-E2DC-2FD9-F854-53218E607BFB}"/>
+          </ac:spMkLst>
+        </pc:spChg>
+        <pc:spChg chg="add del">
+          <ac:chgData name="Joul Espinoza" userId="8b4f8c1dfa2d7319" providerId="LiveId" clId="{4BDD1575-694C-44DC-A5EA-6A642F0D5B4A}" dt="2025-01-26T02:58:13.819" v="1710" actId="478"/>
+          <ac:spMkLst>
+            <pc:docMk/>
+            <pc:sldMk cId="1763628168" sldId="257"/>
+            <ac:spMk id="1062" creationId="{5C4F1101-D9A9-FBC0-0694-B38C3F3FCC49}"/>
+          </ac:spMkLst>
+        </pc:spChg>
+        <pc:spChg chg="add del">
+          <ac:chgData name="Joul Espinoza" userId="8b4f8c1dfa2d7319" providerId="LiveId" clId="{4BDD1575-694C-44DC-A5EA-6A642F0D5B4A}" dt="2025-01-26T02:58:34.545" v="1712" actId="478"/>
+          <ac:spMkLst>
+            <pc:docMk/>
+            <pc:sldMk cId="1763628168" sldId="257"/>
+            <ac:spMk id="1063" creationId="{ACC673EF-46C0-6122-DDB4-691ABC05417E}"/>
+          </ac:spMkLst>
+        </pc:spChg>
+        <pc:spChg chg="add del">
+          <ac:chgData name="Joul Espinoza" userId="8b4f8c1dfa2d7319" providerId="LiveId" clId="{4BDD1575-694C-44DC-A5EA-6A642F0D5B4A}" dt="2025-01-26T02:58:43.891" v="1714" actId="478"/>
+          <ac:spMkLst>
+            <pc:docMk/>
+            <pc:sldMk cId="1763628168" sldId="257"/>
+            <ac:spMk id="1064" creationId="{786D076C-BE8D-BDB4-19DB-C33DB984262E}"/>
           </ac:spMkLst>
         </pc:spChg>
         <pc:spChg chg="add mod">
@@ -590,7 +694,87 @@
           <ac:spMkLst>
             <pc:docMk/>
             <pc:sldMk cId="1763628168" sldId="257"/>
+            <ac:spMk id="1066" creationId="{C57FA6F0-77D6-5FB2-9CA0-579C4AC5FACD}"/>
+          </ac:spMkLst>
+        </pc:spChg>
+        <pc:spChg chg="add mod">
+          <ac:chgData name="Joul Espinoza" userId="8b4f8c1dfa2d7319" providerId="LiveId" clId="{4BDD1575-694C-44DC-A5EA-6A642F0D5B4A}" dt="2025-01-26T03:01:20.621" v="1787" actId="1036"/>
+          <ac:spMkLst>
+            <pc:docMk/>
+            <pc:sldMk cId="1763628168" sldId="257"/>
+            <ac:spMk id="1067" creationId="{6826E033-CE09-4304-FCD0-E9F2CD781050}"/>
+          </ac:spMkLst>
+        </pc:spChg>
+        <pc:spChg chg="add mod">
+          <ac:chgData name="Joul Espinoza" userId="8b4f8c1dfa2d7319" providerId="LiveId" clId="{4BDD1575-694C-44DC-A5EA-6A642F0D5B4A}" dt="2025-01-26T03:01:20.621" v="1787" actId="1036"/>
+          <ac:spMkLst>
+            <pc:docMk/>
+            <pc:sldMk cId="1763628168" sldId="257"/>
+            <ac:spMk id="1068" creationId="{BC9EC747-18B8-3E29-1C99-110492179716}"/>
+          </ac:spMkLst>
+        </pc:spChg>
+        <pc:spChg chg="add mod">
+          <ac:chgData name="Joul Espinoza" userId="8b4f8c1dfa2d7319" providerId="LiveId" clId="{4BDD1575-694C-44DC-A5EA-6A642F0D5B4A}" dt="2025-01-26T03:01:20.621" v="1787" actId="1036"/>
+          <ac:spMkLst>
+            <pc:docMk/>
+            <pc:sldMk cId="1763628168" sldId="257"/>
+            <ac:spMk id="1069" creationId="{EB76A209-17DD-162D-5083-A246D2F3826E}"/>
+          </ac:spMkLst>
+        </pc:spChg>
+        <pc:spChg chg="add mod">
+          <ac:chgData name="Joul Espinoza" userId="8b4f8c1dfa2d7319" providerId="LiveId" clId="{4BDD1575-694C-44DC-A5EA-6A642F0D5B4A}" dt="2025-01-26T03:01:20.621" v="1787" actId="1036"/>
+          <ac:spMkLst>
+            <pc:docMk/>
+            <pc:sldMk cId="1763628168" sldId="257"/>
+            <ac:spMk id="1070" creationId="{2FE18C1C-DA5A-CC16-0F29-DFBF19BC69B2}"/>
+          </ac:spMkLst>
+        </pc:spChg>
+        <pc:spChg chg="add mod">
+          <ac:chgData name="Joul Espinoza" userId="8b4f8c1dfa2d7319" providerId="LiveId" clId="{4BDD1575-694C-44DC-A5EA-6A642F0D5B4A}" dt="2025-01-25T20:59:37.961" v="1406" actId="1076"/>
+          <ac:spMkLst>
+            <pc:docMk/>
+            <pc:sldMk cId="1763628168" sldId="257"/>
             <ac:spMk id="1071" creationId="{D4BCFFF4-B911-F03B-E996-D78238BB7F29}"/>
+          </ac:spMkLst>
+        </pc:spChg>
+        <pc:spChg chg="add mod">
+          <ac:chgData name="Joul Espinoza" userId="8b4f8c1dfa2d7319" providerId="LiveId" clId="{4BDD1575-694C-44DC-A5EA-6A642F0D5B4A}" dt="2025-01-26T03:01:54.226" v="1812" actId="404"/>
+          <ac:spMkLst>
+            <pc:docMk/>
+            <pc:sldMk cId="1763628168" sldId="257"/>
+            <ac:spMk id="1071" creationId="{DE956117-0AE2-4CAB-FF42-86D4C739D0F1}"/>
+          </ac:spMkLst>
+        </pc:spChg>
+        <pc:spChg chg="add mod">
+          <ac:chgData name="Joul Espinoza" userId="8b4f8c1dfa2d7319" providerId="LiveId" clId="{4BDD1575-694C-44DC-A5EA-6A642F0D5B4A}" dt="2025-01-26T03:01:20.621" v="1787" actId="1036"/>
+          <ac:spMkLst>
+            <pc:docMk/>
+            <pc:sldMk cId="1763628168" sldId="257"/>
+            <ac:spMk id="1072" creationId="{92EDC502-9584-C83B-4A02-81BA101B958A}"/>
+          </ac:spMkLst>
+        </pc:spChg>
+        <pc:spChg chg="add mod">
+          <ac:chgData name="Joul Espinoza" userId="8b4f8c1dfa2d7319" providerId="LiveId" clId="{4BDD1575-694C-44DC-A5EA-6A642F0D5B4A}" dt="2025-01-26T03:01:20.621" v="1787" actId="1036"/>
+          <ac:spMkLst>
+            <pc:docMk/>
+            <pc:sldMk cId="1763628168" sldId="257"/>
+            <ac:spMk id="1073" creationId="{555B6E6C-11D9-A928-A9BD-5F3A3B0F5525}"/>
+          </ac:spMkLst>
+        </pc:spChg>
+        <pc:spChg chg="add mod">
+          <ac:chgData name="Joul Espinoza" userId="8b4f8c1dfa2d7319" providerId="LiveId" clId="{4BDD1575-694C-44DC-A5EA-6A642F0D5B4A}" dt="2025-01-26T03:01:20.621" v="1787" actId="1036"/>
+          <ac:spMkLst>
+            <pc:docMk/>
+            <pc:sldMk cId="1763628168" sldId="257"/>
+            <ac:spMk id="1074" creationId="{47D97F6C-1108-3E26-9D1A-D1ECCD709D68}"/>
+          </ac:spMkLst>
+        </pc:spChg>
+        <pc:spChg chg="add mod">
+          <ac:chgData name="Joul Espinoza" userId="8b4f8c1dfa2d7319" providerId="LiveId" clId="{4BDD1575-694C-44DC-A5EA-6A642F0D5B4A}" dt="2025-01-26T03:05:11.215" v="1912" actId="1036"/>
+          <ac:spMkLst>
+            <pc:docMk/>
+            <pc:sldMk cId="1763628168" sldId="257"/>
+            <ac:spMk id="1075" creationId="{594073A8-9EDC-7457-F4E5-3D3C54DA55E5}"/>
           </ac:spMkLst>
         </pc:spChg>
         <pc:spChg chg="add mod">
@@ -618,11 +802,19 @@
           </ac:spMkLst>
         </pc:spChg>
         <pc:spChg chg="add mod">
-          <ac:chgData name="Joul Espinoza" userId="8b4f8c1dfa2d7319" providerId="LiveId" clId="{4BDD1575-694C-44DC-A5EA-6A642F0D5B4A}" dt="2025-01-25T20:59:37.961" v="1406" actId="1076"/>
+          <ac:chgData name="Joul Espinoza" userId="8b4f8c1dfa2d7319" providerId="LiveId" clId="{4BDD1575-694C-44DC-A5EA-6A642F0D5B4A}" dt="2025-01-26T03:01:08.311" v="1765" actId="1036"/>
           <ac:spMkLst>
             <pc:docMk/>
             <pc:sldMk cId="1763628168" sldId="257"/>
-            <ac:spMk id="1082" creationId="{4845FD53-1082-7CAA-8145-FDCCB82CD6E1}"/>
+            <ac:spMk id="1078" creationId="{FD5E4104-F7EC-45B2-39BF-F9E8EDF1EF1B}"/>
+          </ac:spMkLst>
+        </pc:spChg>
+        <pc:spChg chg="add mod">
+          <ac:chgData name="Joul Espinoza" userId="8b4f8c1dfa2d7319" providerId="LiveId" clId="{4BDD1575-694C-44DC-A5EA-6A642F0D5B4A}" dt="2025-01-26T03:05:11.215" v="1912" actId="1036"/>
+          <ac:spMkLst>
+            <pc:docMk/>
+            <pc:sldMk cId="1763628168" sldId="257"/>
+            <ac:spMk id="1079" creationId="{44E4FE94-6F3B-A46F-1AE6-EEC1B1F9E992}"/>
           </ac:spMkLst>
         </pc:spChg>
         <pc:spChg chg="add mod">
@@ -630,7 +822,31 @@
           <ac:spMkLst>
             <pc:docMk/>
             <pc:sldMk cId="1763628168" sldId="257"/>
+            <ac:spMk id="1082" creationId="{4845FD53-1082-7CAA-8145-FDCCB82CD6E1}"/>
+          </ac:spMkLst>
+        </pc:spChg>
+        <pc:spChg chg="add mod">
+          <ac:chgData name="Joul Espinoza" userId="8b4f8c1dfa2d7319" providerId="LiveId" clId="{4BDD1575-694C-44DC-A5EA-6A642F0D5B4A}" dt="2025-01-26T03:04:25.867" v="1875" actId="1076"/>
+          <ac:spMkLst>
+            <pc:docMk/>
+            <pc:sldMk cId="1763628168" sldId="257"/>
+            <ac:spMk id="1082" creationId="{8EB1580E-2436-01E6-76E5-CF865BF3203D}"/>
+          </ac:spMkLst>
+        </pc:spChg>
+        <pc:spChg chg="add mod">
+          <ac:chgData name="Joul Espinoza" userId="8b4f8c1dfa2d7319" providerId="LiveId" clId="{4BDD1575-694C-44DC-A5EA-6A642F0D5B4A}" dt="2025-01-25T20:59:37.961" v="1406" actId="1076"/>
+          <ac:spMkLst>
+            <pc:docMk/>
+            <pc:sldMk cId="1763628168" sldId="257"/>
             <ac:spMk id="1083" creationId="{219749AE-7E6E-6150-3BB2-8183B233BB25}"/>
+          </ac:spMkLst>
+        </pc:spChg>
+        <pc:spChg chg="add mod">
+          <ac:chgData name="Joul Espinoza" userId="8b4f8c1dfa2d7319" providerId="LiveId" clId="{4BDD1575-694C-44DC-A5EA-6A642F0D5B4A}" dt="2025-01-26T03:05:14.991" v="1917" actId="1035"/>
+          <ac:spMkLst>
+            <pc:docMk/>
+            <pc:sldMk cId="1763628168" sldId="257"/>
+            <ac:spMk id="1083" creationId="{B4A5A064-5C9E-A8E1-42DF-4892741B3C02}"/>
           </ac:spMkLst>
         </pc:spChg>
         <pc:spChg chg="add mod">
@@ -649,12 +865,36 @@
             <ac:spMk id="1088" creationId="{1FF00877-D40D-E8FB-D1D0-E68534154AAA}"/>
           </ac:spMkLst>
         </pc:spChg>
+        <pc:spChg chg="add mod">
+          <ac:chgData name="Joul Espinoza" userId="8b4f8c1dfa2d7319" providerId="LiveId" clId="{4BDD1575-694C-44DC-A5EA-6A642F0D5B4A}" dt="2025-01-26T03:05:29.296" v="1921" actId="208"/>
+          <ac:spMkLst>
+            <pc:docMk/>
+            <pc:sldMk cId="1763628168" sldId="257"/>
+            <ac:spMk id="1088" creationId="{39AB4170-0B9F-476D-6B0A-AD9B6D201C56}"/>
+          </ac:spMkLst>
+        </pc:spChg>
+        <pc:spChg chg="add mod">
+          <ac:chgData name="Joul Espinoza" userId="8b4f8c1dfa2d7319" providerId="LiveId" clId="{4BDD1575-694C-44DC-A5EA-6A642F0D5B4A}" dt="2025-01-26T03:06:42.799" v="2056" actId="1076"/>
+          <ac:spMkLst>
+            <pc:docMk/>
+            <pc:sldMk cId="1763628168" sldId="257"/>
+            <ac:spMk id="1093" creationId="{9779888C-D160-AE21-812F-303B87F7774D}"/>
+          </ac:spMkLst>
+        </pc:spChg>
         <pc:spChg chg="add del mod">
           <ac:chgData name="Joul Espinoza" userId="8b4f8c1dfa2d7319" providerId="LiveId" clId="{4BDD1575-694C-44DC-A5EA-6A642F0D5B4A}" dt="2025-01-25T20:59:54.480" v="1408" actId="478"/>
           <ac:spMkLst>
             <pc:docMk/>
             <pc:sldMk cId="1763628168" sldId="257"/>
             <ac:spMk id="1094" creationId="{7C2AAA12-38A7-4077-9D8E-0C350C4BCCF9}"/>
+          </ac:spMkLst>
+        </pc:spChg>
+        <pc:spChg chg="add mod">
+          <ac:chgData name="Joul Espinoza" userId="8b4f8c1dfa2d7319" providerId="LiveId" clId="{4BDD1575-694C-44DC-A5EA-6A642F0D5B4A}" dt="2025-01-26T03:07:49.046" v="2182" actId="1076"/>
+          <ac:spMkLst>
+            <pc:docMk/>
+            <pc:sldMk cId="1763628168" sldId="257"/>
+            <ac:spMk id="1096" creationId="{54AAA9F7-3D44-D790-C937-2927629AE6BA}"/>
           </ac:spMkLst>
         </pc:spChg>
         <pc:spChg chg="add del mod">
@@ -1009,6 +1249,102 @@
             <ac:picMk id="1040" creationId="{21BB6BFB-D592-242B-36BF-E679EF537692}"/>
           </ac:picMkLst>
         </pc:picChg>
+        <pc:picChg chg="add del mod">
+          <ac:chgData name="Joul Espinoza" userId="8b4f8c1dfa2d7319" providerId="LiveId" clId="{4BDD1575-694C-44DC-A5EA-6A642F0D5B4A}" dt="2025-01-26T03:00:45.035" v="1738" actId="1076"/>
+          <ac:picMkLst>
+            <pc:docMk/>
+            <pc:sldMk cId="1763628168" sldId="257"/>
+            <ac:picMk id="1053" creationId="{93390256-5E53-5BCE-2880-7A1068A0688A}"/>
+          </ac:picMkLst>
+        </pc:picChg>
+        <pc:picChg chg="add mod">
+          <ac:chgData name="Joul Espinoza" userId="8b4f8c1dfa2d7319" providerId="LiveId" clId="{4BDD1575-694C-44DC-A5EA-6A642F0D5B4A}" dt="2025-01-26T02:57:21.677" v="1704" actId="1035"/>
+          <ac:picMkLst>
+            <pc:docMk/>
+            <pc:sldMk cId="1763628168" sldId="257"/>
+            <ac:picMk id="1059" creationId="{4F2943EA-864A-B030-012E-21908DA43864}"/>
+          </ac:picMkLst>
+        </pc:picChg>
+        <pc:picChg chg="add mod">
+          <ac:chgData name="Joul Espinoza" userId="8b4f8c1dfa2d7319" providerId="LiveId" clId="{4BDD1575-694C-44DC-A5EA-6A642F0D5B4A}" dt="2025-01-26T03:03:07.484" v="1824" actId="1366"/>
+          <ac:picMkLst>
+            <pc:docMk/>
+            <pc:sldMk cId="1763628168" sldId="257"/>
+            <ac:picMk id="1066" creationId="{70FB36E3-A911-79F6-4C18-995CB50F7FF8}"/>
+          </ac:picMkLst>
+        </pc:picChg>
+        <pc:picChg chg="add mod">
+          <ac:chgData name="Joul Espinoza" userId="8b4f8c1dfa2d7319" providerId="LiveId" clId="{4BDD1575-694C-44DC-A5EA-6A642F0D5B4A}" dt="2025-01-26T03:01:20.621" v="1787" actId="1036"/>
+          <ac:picMkLst>
+            <pc:docMk/>
+            <pc:sldMk cId="1763628168" sldId="257"/>
+            <ac:picMk id="1077" creationId="{154591BE-69A5-0E73-EA2F-47BA507BE59F}"/>
+          </ac:picMkLst>
+        </pc:picChg>
+        <pc:picChg chg="add mod">
+          <ac:chgData name="Joul Espinoza" userId="8b4f8c1dfa2d7319" providerId="LiveId" clId="{4BDD1575-694C-44DC-A5EA-6A642F0D5B4A}" dt="2025-01-26T03:03:41.764" v="1831" actId="1076"/>
+          <ac:picMkLst>
+            <pc:docMk/>
+            <pc:sldMk cId="1763628168" sldId="257"/>
+            <ac:picMk id="1080" creationId="{3561FA69-1061-A605-C368-4D1BF9E9DE43}"/>
+          </ac:picMkLst>
+        </pc:picChg>
+        <pc:picChg chg="add mod">
+          <ac:chgData name="Joul Espinoza" userId="8b4f8c1dfa2d7319" providerId="LiveId" clId="{4BDD1575-694C-44DC-A5EA-6A642F0D5B4A}" dt="2025-01-26T03:03:44.045" v="1832" actId="1076"/>
+          <ac:picMkLst>
+            <pc:docMk/>
+            <pc:sldMk cId="1763628168" sldId="257"/>
+            <ac:picMk id="1081" creationId="{F8785948-9C15-4756-BD41-4141B1652469}"/>
+          </ac:picMkLst>
+        </pc:picChg>
+        <pc:picChg chg="add mod">
+          <ac:chgData name="Joul Espinoza" userId="8b4f8c1dfa2d7319" providerId="LiveId" clId="{4BDD1575-694C-44DC-A5EA-6A642F0D5B4A}" dt="2025-01-26T03:04:38.971" v="1890" actId="1076"/>
+          <ac:picMkLst>
+            <pc:docMk/>
+            <pc:sldMk cId="1763628168" sldId="257"/>
+            <ac:picMk id="1084" creationId="{1E16FB34-37DF-6059-F46B-AD18E12286CD}"/>
+          </ac:picMkLst>
+        </pc:picChg>
+        <pc:picChg chg="add mod">
+          <ac:chgData name="Joul Espinoza" userId="8b4f8c1dfa2d7319" providerId="LiveId" clId="{4BDD1575-694C-44DC-A5EA-6A642F0D5B4A}" dt="2025-01-26T03:04:38.971" v="1890" actId="1076"/>
+          <ac:picMkLst>
+            <pc:docMk/>
+            <pc:sldMk cId="1763628168" sldId="257"/>
+            <ac:picMk id="1085" creationId="{CFB6BDC1-D08A-FBDD-2965-ECC3A80B81D3}"/>
+          </ac:picMkLst>
+        </pc:picChg>
+        <pc:picChg chg="add mod">
+          <ac:chgData name="Joul Espinoza" userId="8b4f8c1dfa2d7319" providerId="LiveId" clId="{4BDD1575-694C-44DC-A5EA-6A642F0D5B4A}" dt="2025-01-26T03:05:14.991" v="1917" actId="1035"/>
+          <ac:picMkLst>
+            <pc:docMk/>
+            <pc:sldMk cId="1763628168" sldId="257"/>
+            <ac:picMk id="1086" creationId="{E2881DF5-97DB-E93E-FA30-C42165E090ED}"/>
+          </ac:picMkLst>
+        </pc:picChg>
+        <pc:picChg chg="add mod">
+          <ac:chgData name="Joul Espinoza" userId="8b4f8c1dfa2d7319" providerId="LiveId" clId="{4BDD1575-694C-44DC-A5EA-6A642F0D5B4A}" dt="2025-01-26T03:05:14.991" v="1917" actId="1035"/>
+          <ac:picMkLst>
+            <pc:docMk/>
+            <pc:sldMk cId="1763628168" sldId="257"/>
+            <ac:picMk id="1087" creationId="{6A1672A8-C680-957C-3EB1-C9C26D5911CF}"/>
+          </ac:picMkLst>
+        </pc:picChg>
+        <pc:picChg chg="add mod">
+          <ac:chgData name="Joul Espinoza" userId="8b4f8c1dfa2d7319" providerId="LiveId" clId="{4BDD1575-694C-44DC-A5EA-6A642F0D5B4A}" dt="2025-01-26T03:05:19.143" v="1919" actId="1076"/>
+          <ac:picMkLst>
+            <pc:docMk/>
+            <pc:sldMk cId="1763628168" sldId="257"/>
+            <ac:picMk id="1089" creationId="{D7E531F1-4D94-FDAD-838B-D3B5FAD07754}"/>
+          </ac:picMkLst>
+        </pc:picChg>
+        <pc:picChg chg="add mod">
+          <ac:chgData name="Joul Espinoza" userId="8b4f8c1dfa2d7319" providerId="LiveId" clId="{4BDD1575-694C-44DC-A5EA-6A642F0D5B4A}" dt="2025-01-26T03:05:19.143" v="1919" actId="1076"/>
+          <ac:picMkLst>
+            <pc:docMk/>
+            <pc:sldMk cId="1763628168" sldId="257"/>
+            <ac:picMk id="1090" creationId="{921CD076-B1EE-94B7-58C0-8F7A7990A40B}"/>
+          </ac:picMkLst>
+        </pc:picChg>
         <pc:cxnChg chg="add mod">
           <ac:chgData name="Joul Espinoza" userId="8b4f8c1dfa2d7319" providerId="LiveId" clId="{4BDD1575-694C-44DC-A5EA-6A642F0D5B4A}" dt="2025-01-25T20:27:39.266" v="439" actId="1035"/>
           <ac:cxnSpMkLst>
@@ -1042,6 +1378,14 @@
           </ac:cxnSpMkLst>
         </pc:cxnChg>
         <pc:cxnChg chg="add mod">
+          <ac:chgData name="Joul Espinoza" userId="8b4f8c1dfa2d7319" providerId="LiveId" clId="{4BDD1575-694C-44DC-A5EA-6A642F0D5B4A}" dt="2025-01-26T02:52:00.326" v="1611" actId="14100"/>
+          <ac:cxnSpMkLst>
+            <pc:docMk/>
+            <pc:sldMk cId="1763628168" sldId="257"/>
+            <ac:cxnSpMk id="1033" creationId="{A650AA8C-610B-56E3-6C83-AC7B915F78E3}"/>
+          </ac:cxnSpMkLst>
+        </pc:cxnChg>
+        <pc:cxnChg chg="add mod">
           <ac:chgData name="Joul Espinoza" userId="8b4f8c1dfa2d7319" providerId="LiveId" clId="{4BDD1575-694C-44DC-A5EA-6A642F0D5B4A}" dt="2025-01-25T20:49:53.549" v="1113" actId="1035"/>
           <ac:cxnSpMkLst>
             <pc:docMk/>
@@ -1063,6 +1407,22 @@
             <pc:docMk/>
             <pc:sldMk cId="1763628168" sldId="257"/>
             <ac:cxnSpMk id="1057" creationId="{9BA24F5D-F1C6-F8FE-E092-A12722A28C38}"/>
+          </ac:cxnSpMkLst>
+        </pc:cxnChg>
+        <pc:cxnChg chg="add mod">
+          <ac:chgData name="Joul Espinoza" userId="8b4f8c1dfa2d7319" providerId="LiveId" clId="{4BDD1575-694C-44DC-A5EA-6A642F0D5B4A}" dt="2025-01-26T03:06:06.391" v="1944" actId="1035"/>
+          <ac:cxnSpMkLst>
+            <pc:docMk/>
+            <pc:sldMk cId="1763628168" sldId="257"/>
+            <ac:cxnSpMk id="1091" creationId="{806F81C2-3092-A5B8-9A75-8BC91C87FFAE}"/>
+          </ac:cxnSpMkLst>
+        </pc:cxnChg>
+        <pc:cxnChg chg="add mod">
+          <ac:chgData name="Joul Espinoza" userId="8b4f8c1dfa2d7319" providerId="LiveId" clId="{4BDD1575-694C-44DC-A5EA-6A642F0D5B4A}" dt="2025-01-26T03:07:16.389" v="2059" actId="14100"/>
+          <ac:cxnSpMkLst>
+            <pc:docMk/>
+            <pc:sldMk cId="1763628168" sldId="257"/>
+            <ac:cxnSpMk id="1094" creationId="{855CA1F2-C6D6-1136-EAE5-2DDC6D4DC9B3}"/>
           </ac:cxnSpMkLst>
         </pc:cxnChg>
         <pc:cxnChg chg="add mod">
@@ -10860,7 +11220,7 @@
           <a:lstStyle/>
           <a:p>
             <a:pPr algn="ctr"/>
-            <a:endParaRPr lang="es-MX"/>
+            <a:endParaRPr lang="es-MX" dirty="0"/>
           </a:p>
         </p:txBody>
       </p:sp>
@@ -11135,6 +11495,2093 @@
                 </a:outerShdw>
               </a:effectLst>
             </a:endParaRPr>
+          </a:p>
+        </p:txBody>
+      </p:sp>
+      <p:sp>
+        <p:nvSpPr>
+          <p:cNvPr id="6" name="Rectángulo 5">
+            <a:extLst>
+              <a:ext uri="{FF2B5EF4-FFF2-40B4-BE49-F238E27FC236}">
+                <a16:creationId xmlns:a16="http://schemas.microsoft.com/office/drawing/2014/main" id="{3C41C4FC-8876-3EBB-A993-2089976E4A1F}"/>
+              </a:ext>
+            </a:extLst>
+          </p:cNvPr>
+          <p:cNvSpPr/>
+          <p:nvPr/>
+        </p:nvSpPr>
+        <p:spPr>
+          <a:xfrm>
+            <a:off x="287677" y="3776515"/>
+            <a:ext cx="1438199" cy="184666"/>
+          </a:xfrm>
+          <a:prstGeom prst="rect">
+            <a:avLst/>
+          </a:prstGeom>
+          <a:noFill/>
+        </p:spPr>
+        <p:txBody>
+          <a:bodyPr wrap="square" lIns="91440" tIns="45720" rIns="91440" bIns="45720">
+            <a:spAutoFit/>
+          </a:bodyPr>
+          <a:lstStyle/>
+          <a:p>
+            <a:r>
+              <a:rPr lang="es-ES" sz="600" dirty="0">
+                <a:ln w="0"/>
+                <a:effectLst>
+                  <a:outerShdw blurRad="38100" dist="19050" dir="2700000" algn="tl" rotWithShape="0">
+                    <a:schemeClr val="dk1">
+                      <a:alpha val="40000"/>
+                    </a:schemeClr>
+                  </a:outerShdw>
+                </a:effectLst>
+              </a:rPr>
+              <a:t>Nombre:</a:t>
+            </a:r>
+            <a:endParaRPr lang="es-ES" sz="600" b="0" cap="none" spc="0" dirty="0">
+              <a:ln w="0"/>
+              <a:solidFill>
+                <a:schemeClr val="tx1"/>
+              </a:solidFill>
+              <a:effectLst>
+                <a:outerShdw blurRad="38100" dist="19050" dir="2700000" algn="tl" rotWithShape="0">
+                  <a:schemeClr val="dk1">
+                    <a:alpha val="40000"/>
+                  </a:schemeClr>
+                </a:outerShdw>
+              </a:effectLst>
+            </a:endParaRPr>
+          </a:p>
+        </p:txBody>
+      </p:sp>
+      <p:sp>
+        <p:nvSpPr>
+          <p:cNvPr id="12" name="Rectángulo 11">
+            <a:extLst>
+              <a:ext uri="{FF2B5EF4-FFF2-40B4-BE49-F238E27FC236}">
+                <a16:creationId xmlns:a16="http://schemas.microsoft.com/office/drawing/2014/main" id="{36838F62-F8D4-63BA-9CC6-5E059811246C}"/>
+              </a:ext>
+            </a:extLst>
+          </p:cNvPr>
+          <p:cNvSpPr/>
+          <p:nvPr/>
+        </p:nvSpPr>
+        <p:spPr>
+          <a:xfrm>
+            <a:off x="383008" y="3934186"/>
+            <a:ext cx="1255298" cy="106357"/>
+          </a:xfrm>
+          <a:prstGeom prst="rect">
+            <a:avLst/>
+          </a:prstGeom>
+          <a:solidFill>
+            <a:schemeClr val="bg1"/>
+          </a:solidFill>
+          <a:ln w="6350">
+            <a:solidFill>
+              <a:schemeClr val="tx1"/>
+            </a:solidFill>
+          </a:ln>
+        </p:spPr>
+        <p:style>
+          <a:lnRef idx="2">
+            <a:schemeClr val="accent1">
+              <a:shade val="15000"/>
+            </a:schemeClr>
+          </a:lnRef>
+          <a:fillRef idx="1">
+            <a:schemeClr val="accent1"/>
+          </a:fillRef>
+          <a:effectRef idx="0">
+            <a:schemeClr val="accent1"/>
+          </a:effectRef>
+          <a:fontRef idx="minor">
+            <a:schemeClr val="lt1"/>
+          </a:fontRef>
+        </p:style>
+        <p:txBody>
+          <a:bodyPr rtlCol="0" anchor="ctr"/>
+          <a:lstStyle/>
+          <a:p>
+            <a:pPr algn="ctr"/>
+            <a:endParaRPr lang="es-MX"/>
+          </a:p>
+        </p:txBody>
+      </p:sp>
+      <p:sp>
+        <p:nvSpPr>
+          <p:cNvPr id="36" name="Rectángulo 35">
+            <a:extLst>
+              <a:ext uri="{FF2B5EF4-FFF2-40B4-BE49-F238E27FC236}">
+                <a16:creationId xmlns:a16="http://schemas.microsoft.com/office/drawing/2014/main" id="{005FC1BB-DBE4-6242-3354-F6626A7A59C0}"/>
+              </a:ext>
+            </a:extLst>
+          </p:cNvPr>
+          <p:cNvSpPr/>
+          <p:nvPr/>
+        </p:nvSpPr>
+        <p:spPr>
+          <a:xfrm>
+            <a:off x="287677" y="4033822"/>
+            <a:ext cx="1438199" cy="184666"/>
+          </a:xfrm>
+          <a:prstGeom prst="rect">
+            <a:avLst/>
+          </a:prstGeom>
+          <a:noFill/>
+        </p:spPr>
+        <p:txBody>
+          <a:bodyPr wrap="square" lIns="91440" tIns="45720" rIns="91440" bIns="45720">
+            <a:spAutoFit/>
+          </a:bodyPr>
+          <a:lstStyle/>
+          <a:p>
+            <a:r>
+              <a:rPr lang="es-ES" sz="600" dirty="0">
+                <a:ln w="0"/>
+                <a:effectLst>
+                  <a:outerShdw blurRad="38100" dist="19050" dir="2700000" algn="tl" rotWithShape="0">
+                    <a:schemeClr val="dk1">
+                      <a:alpha val="40000"/>
+                    </a:schemeClr>
+                  </a:outerShdw>
+                </a:effectLst>
+              </a:rPr>
+              <a:t>Imagen:</a:t>
+            </a:r>
+            <a:endParaRPr lang="es-ES" sz="600" b="0" cap="none" spc="0" dirty="0">
+              <a:ln w="0"/>
+              <a:solidFill>
+                <a:schemeClr val="tx1"/>
+              </a:solidFill>
+              <a:effectLst>
+                <a:outerShdw blurRad="38100" dist="19050" dir="2700000" algn="tl" rotWithShape="0">
+                  <a:schemeClr val="dk1">
+                    <a:alpha val="40000"/>
+                  </a:schemeClr>
+                </a:outerShdw>
+              </a:effectLst>
+            </a:endParaRPr>
+          </a:p>
+        </p:txBody>
+      </p:sp>
+      <p:sp>
+        <p:nvSpPr>
+          <p:cNvPr id="38" name="Rectángulo 37">
+            <a:extLst>
+              <a:ext uri="{FF2B5EF4-FFF2-40B4-BE49-F238E27FC236}">
+                <a16:creationId xmlns:a16="http://schemas.microsoft.com/office/drawing/2014/main" id="{438E8FF0-9311-7871-44CC-F5E33C4FC3D3}"/>
+              </a:ext>
+            </a:extLst>
+          </p:cNvPr>
+          <p:cNvSpPr/>
+          <p:nvPr/>
+        </p:nvSpPr>
+        <p:spPr>
+          <a:xfrm>
+            <a:off x="718174" y="4186290"/>
+            <a:ext cx="504000" cy="504000"/>
+          </a:xfrm>
+          <a:prstGeom prst="rect">
+            <a:avLst/>
+          </a:prstGeom>
+          <a:solidFill>
+            <a:schemeClr val="bg1"/>
+          </a:solidFill>
+          <a:ln w="9525">
+            <a:solidFill>
+              <a:schemeClr val="tx1"/>
+            </a:solidFill>
+          </a:ln>
+        </p:spPr>
+        <p:style>
+          <a:lnRef idx="2">
+            <a:schemeClr val="accent1">
+              <a:shade val="15000"/>
+            </a:schemeClr>
+          </a:lnRef>
+          <a:fillRef idx="1">
+            <a:schemeClr val="accent1"/>
+          </a:fillRef>
+          <a:effectRef idx="0">
+            <a:schemeClr val="accent1"/>
+          </a:effectRef>
+          <a:fontRef idx="minor">
+            <a:schemeClr val="lt1"/>
+          </a:fontRef>
+        </p:style>
+        <p:txBody>
+          <a:bodyPr rtlCol="0" anchor="ctr"/>
+          <a:lstStyle/>
+          <a:p>
+            <a:pPr algn="ctr"/>
+            <a:r>
+              <a:rPr lang="es-MX" sz="2800" dirty="0">
+                <a:solidFill>
+                  <a:schemeClr val="tx1"/>
+                </a:solidFill>
+              </a:rPr>
+              <a:t>+</a:t>
+            </a:r>
+          </a:p>
+        </p:txBody>
+      </p:sp>
+      <p:cxnSp>
+        <p:nvCxnSpPr>
+          <p:cNvPr id="1033" name="Conector: curvado 1032">
+            <a:extLst>
+              <a:ext uri="{FF2B5EF4-FFF2-40B4-BE49-F238E27FC236}">
+                <a16:creationId xmlns:a16="http://schemas.microsoft.com/office/drawing/2014/main" id="{A650AA8C-610B-56E3-6C83-AC7B915F78E3}"/>
+              </a:ext>
+            </a:extLst>
+          </p:cNvPr>
+          <p:cNvCxnSpPr>
+            <a:cxnSpLocks/>
+          </p:cNvCxnSpPr>
+          <p:nvPr/>
+        </p:nvCxnSpPr>
+        <p:spPr>
+          <a:xfrm rot="10800000" flipV="1">
+            <a:off x="-109728" y="4409514"/>
+            <a:ext cx="791372" cy="169135"/>
+          </a:xfrm>
+          <a:prstGeom prst="curvedConnector3">
+            <a:avLst>
+              <a:gd name="adj1" fmla="val 50000"/>
+            </a:avLst>
+          </a:prstGeom>
+          <a:ln>
+            <a:solidFill>
+              <a:srgbClr val="002060"/>
+            </a:solidFill>
+            <a:tailEnd type="triangle"/>
+          </a:ln>
+        </p:spPr>
+        <p:style>
+          <a:lnRef idx="2">
+            <a:schemeClr val="accent1"/>
+          </a:lnRef>
+          <a:fillRef idx="0">
+            <a:schemeClr val="accent1"/>
+          </a:fillRef>
+          <a:effectRef idx="1">
+            <a:schemeClr val="accent1"/>
+          </a:effectRef>
+          <a:fontRef idx="minor">
+            <a:schemeClr val="tx1"/>
+          </a:fontRef>
+        </p:style>
+      </p:cxnSp>
+      <p:sp>
+        <p:nvSpPr>
+          <p:cNvPr id="1054" name="Rectángulo 1053">
+            <a:extLst>
+              <a:ext uri="{FF2B5EF4-FFF2-40B4-BE49-F238E27FC236}">
+                <a16:creationId xmlns:a16="http://schemas.microsoft.com/office/drawing/2014/main" id="{DDE4036C-96CF-13D1-7A7C-447AF206A8BB}"/>
+              </a:ext>
+            </a:extLst>
+          </p:cNvPr>
+          <p:cNvSpPr/>
+          <p:nvPr/>
+        </p:nvSpPr>
+        <p:spPr>
+          <a:xfrm>
+            <a:off x="287677" y="4698286"/>
+            <a:ext cx="1438199" cy="184666"/>
+          </a:xfrm>
+          <a:prstGeom prst="rect">
+            <a:avLst/>
+          </a:prstGeom>
+          <a:noFill/>
+        </p:spPr>
+        <p:txBody>
+          <a:bodyPr wrap="square" lIns="91440" tIns="45720" rIns="91440" bIns="45720">
+            <a:spAutoFit/>
+          </a:bodyPr>
+          <a:lstStyle/>
+          <a:p>
+            <a:r>
+              <a:rPr lang="es-ES" sz="600" dirty="0">
+                <a:ln w="0"/>
+                <a:effectLst>
+                  <a:outerShdw blurRad="38100" dist="19050" dir="2700000" algn="tl" rotWithShape="0">
+                    <a:schemeClr val="dk1">
+                      <a:alpha val="40000"/>
+                    </a:schemeClr>
+                  </a:outerShdw>
+                </a:effectLst>
+              </a:rPr>
+              <a:t>Grupo muscular:</a:t>
+            </a:r>
+            <a:endParaRPr lang="es-ES" sz="600" b="0" cap="none" spc="0" dirty="0">
+              <a:ln w="0"/>
+              <a:solidFill>
+                <a:schemeClr val="tx1"/>
+              </a:solidFill>
+              <a:effectLst>
+                <a:outerShdw blurRad="38100" dist="19050" dir="2700000" algn="tl" rotWithShape="0">
+                  <a:schemeClr val="dk1">
+                    <a:alpha val="40000"/>
+                  </a:schemeClr>
+                </a:outerShdw>
+              </a:effectLst>
+            </a:endParaRPr>
+          </a:p>
+        </p:txBody>
+      </p:sp>
+      <p:sp>
+        <p:nvSpPr>
+          <p:cNvPr id="1057" name="Rectángulo 1056">
+            <a:extLst>
+              <a:ext uri="{FF2B5EF4-FFF2-40B4-BE49-F238E27FC236}">
+                <a16:creationId xmlns:a16="http://schemas.microsoft.com/office/drawing/2014/main" id="{D803A238-D5C5-A9FF-EBAE-AA4CBF52F0B6}"/>
+              </a:ext>
+            </a:extLst>
+          </p:cNvPr>
+          <p:cNvSpPr/>
+          <p:nvPr/>
+        </p:nvSpPr>
+        <p:spPr>
+          <a:xfrm>
+            <a:off x="403777" y="4847360"/>
+            <a:ext cx="1322100" cy="184666"/>
+          </a:xfrm>
+          <a:prstGeom prst="rect">
+            <a:avLst/>
+          </a:prstGeom>
+          <a:noFill/>
+        </p:spPr>
+        <p:txBody>
+          <a:bodyPr wrap="square" lIns="91440" tIns="45720" rIns="91440" bIns="45720">
+            <a:spAutoFit/>
+          </a:bodyPr>
+          <a:lstStyle/>
+          <a:p>
+            <a:r>
+              <a:rPr lang="es-ES" sz="600" dirty="0">
+                <a:ln w="0"/>
+                <a:effectLst>
+                  <a:outerShdw blurRad="38100" dist="19050" dir="2700000" algn="tl" rotWithShape="0">
+                    <a:schemeClr val="dk1">
+                      <a:alpha val="40000"/>
+                    </a:schemeClr>
+                  </a:outerShdw>
+                </a:effectLst>
+              </a:rPr>
+              <a:t>Añadir</a:t>
+            </a:r>
+            <a:endParaRPr lang="es-ES" sz="600" b="0" cap="none" spc="0" dirty="0">
+              <a:ln w="0"/>
+              <a:solidFill>
+                <a:schemeClr val="tx1"/>
+              </a:solidFill>
+              <a:effectLst>
+                <a:outerShdw blurRad="38100" dist="19050" dir="2700000" algn="tl" rotWithShape="0">
+                  <a:schemeClr val="dk1">
+                    <a:alpha val="40000"/>
+                  </a:schemeClr>
+                </a:outerShdw>
+              </a:effectLst>
+            </a:endParaRPr>
+          </a:p>
+        </p:txBody>
+      </p:sp>
+      <p:sp>
+        <p:nvSpPr>
+          <p:cNvPr id="1058" name="Elipse 1057">
+            <a:extLst>
+              <a:ext uri="{FF2B5EF4-FFF2-40B4-BE49-F238E27FC236}">
+                <a16:creationId xmlns:a16="http://schemas.microsoft.com/office/drawing/2014/main" id="{349B4544-4D0E-4EB8-F4AD-5276FCB6BF51}"/>
+              </a:ext>
+            </a:extLst>
+          </p:cNvPr>
+          <p:cNvSpPr/>
+          <p:nvPr/>
+        </p:nvSpPr>
+        <p:spPr>
+          <a:xfrm>
+            <a:off x="356408" y="4884558"/>
+            <a:ext cx="108000" cy="108000"/>
+          </a:xfrm>
+          <a:prstGeom prst="ellipse">
+            <a:avLst/>
+          </a:prstGeom>
+          <a:noFill/>
+          <a:ln w="6350">
+            <a:solidFill>
+              <a:schemeClr val="tx1"/>
+            </a:solidFill>
+          </a:ln>
+        </p:spPr>
+        <p:style>
+          <a:lnRef idx="2">
+            <a:schemeClr val="accent1">
+              <a:shade val="15000"/>
+            </a:schemeClr>
+          </a:lnRef>
+          <a:fillRef idx="1">
+            <a:schemeClr val="accent1"/>
+          </a:fillRef>
+          <a:effectRef idx="0">
+            <a:schemeClr val="accent1"/>
+          </a:effectRef>
+          <a:fontRef idx="minor">
+            <a:schemeClr val="lt1"/>
+          </a:fontRef>
+        </p:style>
+        <p:txBody>
+          <a:bodyPr rtlCol="0" anchor="ctr"/>
+          <a:lstStyle/>
+          <a:p>
+            <a:pPr algn="ctr"/>
+            <a:r>
+              <a:rPr lang="es-MX" sz="1000" dirty="0">
+                <a:solidFill>
+                  <a:schemeClr val="tx1"/>
+                </a:solidFill>
+              </a:rPr>
+              <a:t>+</a:t>
+            </a:r>
+          </a:p>
+        </p:txBody>
+      </p:sp>
+      <p:pic>
+        <p:nvPicPr>
+          <p:cNvPr id="1059" name="Picture 2" descr="Ilustración De Diseño De Icono De Vector De Disquete PNG ,dibujos Disco  Flexible, Disco Flash, Disquete PNG y Vector para Descargar Gratis | Pngtree">
+            <a:extLst>
+              <a:ext uri="{FF2B5EF4-FFF2-40B4-BE49-F238E27FC236}">
+                <a16:creationId xmlns:a16="http://schemas.microsoft.com/office/drawing/2014/main" id="{4F2943EA-864A-B030-012E-21908DA43864}"/>
+              </a:ext>
+            </a:extLst>
+          </p:cNvPr>
+          <p:cNvPicPr>
+            <a:picLocks noChangeAspect="1" noChangeArrowheads="1"/>
+          </p:cNvPicPr>
+          <p:nvPr/>
+        </p:nvPicPr>
+        <p:blipFill>
+          <a:blip r:embed="rId9">
+            <a:extLst>
+              <a:ext uri="{28A0092B-C50C-407E-A947-70E740481C1C}">
+                <a14:useLocalDpi xmlns:a14="http://schemas.microsoft.com/office/drawing/2010/main" val="0"/>
+              </a:ext>
+            </a:extLst>
+          </a:blip>
+          <a:srcRect/>
+          <a:stretch>
+            <a:fillRect/>
+          </a:stretch>
+        </p:blipFill>
+        <p:spPr bwMode="auto">
+          <a:xfrm>
+            <a:off x="1489361" y="3610256"/>
+            <a:ext cx="144000" cy="144000"/>
+          </a:xfrm>
+          <a:prstGeom prst="rect">
+            <a:avLst/>
+          </a:prstGeom>
+          <a:noFill/>
+          <a:extLst>
+            <a:ext uri="{909E8E84-426E-40DD-AFC4-6F175D3DCCD1}">
+              <a14:hiddenFill xmlns:a14="http://schemas.microsoft.com/office/drawing/2010/main">
+                <a:solidFill>
+                  <a:srgbClr val="FFFFFF"/>
+                </a:solidFill>
+              </a14:hiddenFill>
+            </a:ext>
+          </a:extLst>
+        </p:spPr>
+      </p:pic>
+      <p:pic>
+        <p:nvPicPr>
+          <p:cNvPr id="1066" name="Imagen 1065">
+            <a:extLst>
+              <a:ext uri="{FF2B5EF4-FFF2-40B4-BE49-F238E27FC236}">
+                <a16:creationId xmlns:a16="http://schemas.microsoft.com/office/drawing/2014/main" id="{70FB36E3-A911-79F6-4C18-995CB50F7FF8}"/>
+              </a:ext>
+            </a:extLst>
+          </p:cNvPr>
+          <p:cNvPicPr>
+            <a:picLocks noChangeAspect="1"/>
+          </p:cNvPicPr>
+          <p:nvPr/>
+        </p:nvPicPr>
+        <p:blipFill>
+          <a:blip r:embed="rId10">
+            <a:clrChange>
+              <a:clrFrom>
+                <a:srgbClr val="FFFFFF"/>
+              </a:clrFrom>
+              <a:clrTo>
+                <a:srgbClr val="FFFFFF">
+                  <a:alpha val="0"/>
+                </a:srgbClr>
+              </a:clrTo>
+            </a:clrChange>
+            <a:grayscl/>
+          </a:blip>
+          <a:stretch>
+            <a:fillRect/>
+          </a:stretch>
+        </p:blipFill>
+        <p:spPr>
+          <a:xfrm>
+            <a:off x="388340" y="3600474"/>
+            <a:ext cx="132857" cy="144000"/>
+          </a:xfrm>
+          <a:prstGeom prst="rect">
+            <a:avLst/>
+          </a:prstGeom>
+        </p:spPr>
+      </p:pic>
+      <p:sp>
+        <p:nvSpPr>
+          <p:cNvPr id="1067" name="Rectángulo: esquinas redondeadas 1066">
+            <a:extLst>
+              <a:ext uri="{FF2B5EF4-FFF2-40B4-BE49-F238E27FC236}">
+                <a16:creationId xmlns:a16="http://schemas.microsoft.com/office/drawing/2014/main" id="{6826E033-CE09-4304-FCD0-E9F2CD781050}"/>
+              </a:ext>
+            </a:extLst>
+          </p:cNvPr>
+          <p:cNvSpPr/>
+          <p:nvPr/>
+        </p:nvSpPr>
+        <p:spPr>
+          <a:xfrm>
+            <a:off x="-1623380" y="3666528"/>
+            <a:ext cx="1439999" cy="2036409"/>
+          </a:xfrm>
+          <a:prstGeom prst="roundRect">
+            <a:avLst>
+              <a:gd name="adj" fmla="val 10335"/>
+            </a:avLst>
+          </a:prstGeom>
+          <a:solidFill>
+            <a:schemeClr val="bg1"/>
+          </a:solidFill>
+          <a:ln>
+            <a:solidFill>
+              <a:schemeClr val="tx1"/>
+            </a:solidFill>
+          </a:ln>
+        </p:spPr>
+        <p:style>
+          <a:lnRef idx="2">
+            <a:schemeClr val="accent1">
+              <a:shade val="15000"/>
+            </a:schemeClr>
+          </a:lnRef>
+          <a:fillRef idx="1">
+            <a:schemeClr val="accent1"/>
+          </a:fillRef>
+          <a:effectRef idx="0">
+            <a:schemeClr val="accent1"/>
+          </a:effectRef>
+          <a:fontRef idx="minor">
+            <a:schemeClr val="lt1"/>
+          </a:fontRef>
+        </p:style>
+        <p:txBody>
+          <a:bodyPr rtlCol="0" anchor="ctr"/>
+          <a:lstStyle/>
+          <a:p>
+            <a:pPr algn="ctr"/>
+            <a:endParaRPr lang="es-MX" dirty="0"/>
+          </a:p>
+        </p:txBody>
+      </p:sp>
+      <p:sp>
+        <p:nvSpPr>
+          <p:cNvPr id="1068" name="Rectángulo: esquinas redondeadas 1067">
+            <a:extLst>
+              <a:ext uri="{FF2B5EF4-FFF2-40B4-BE49-F238E27FC236}">
+                <a16:creationId xmlns:a16="http://schemas.microsoft.com/office/drawing/2014/main" id="{BC9EC747-18B8-3E29-1C99-110492179716}"/>
+              </a:ext>
+            </a:extLst>
+          </p:cNvPr>
+          <p:cNvSpPr/>
+          <p:nvPr/>
+        </p:nvSpPr>
+        <p:spPr>
+          <a:xfrm>
+            <a:off x="-1049180" y="3702644"/>
+            <a:ext cx="288000" cy="36000"/>
+          </a:xfrm>
+          <a:prstGeom prst="roundRect">
+            <a:avLst/>
+          </a:prstGeom>
+          <a:solidFill>
+            <a:schemeClr val="bg1">
+              <a:lumMod val="65000"/>
+            </a:schemeClr>
+          </a:solidFill>
+          <a:ln>
+            <a:noFill/>
+          </a:ln>
+        </p:spPr>
+        <p:style>
+          <a:lnRef idx="2">
+            <a:schemeClr val="accent1">
+              <a:shade val="15000"/>
+            </a:schemeClr>
+          </a:lnRef>
+          <a:fillRef idx="1">
+            <a:schemeClr val="accent1"/>
+          </a:fillRef>
+          <a:effectRef idx="0">
+            <a:schemeClr val="accent1"/>
+          </a:effectRef>
+          <a:fontRef idx="minor">
+            <a:schemeClr val="lt1"/>
+          </a:fontRef>
+        </p:style>
+        <p:txBody>
+          <a:bodyPr rtlCol="0" anchor="ctr"/>
+          <a:lstStyle/>
+          <a:p>
+            <a:pPr algn="ctr"/>
+            <a:endParaRPr lang="es-MX"/>
+          </a:p>
+        </p:txBody>
+      </p:sp>
+      <p:sp>
+        <p:nvSpPr>
+          <p:cNvPr id="1069" name="Rectángulo 1068">
+            <a:extLst>
+              <a:ext uri="{FF2B5EF4-FFF2-40B4-BE49-F238E27FC236}">
+                <a16:creationId xmlns:a16="http://schemas.microsoft.com/office/drawing/2014/main" id="{EB76A209-17DD-162D-5083-A246D2F3826E}"/>
+              </a:ext>
+            </a:extLst>
+          </p:cNvPr>
+          <p:cNvSpPr/>
+          <p:nvPr/>
+        </p:nvSpPr>
+        <p:spPr>
+          <a:xfrm>
+            <a:off x="-1625166" y="3711708"/>
+            <a:ext cx="1438199" cy="215444"/>
+          </a:xfrm>
+          <a:prstGeom prst="rect">
+            <a:avLst/>
+          </a:prstGeom>
+          <a:noFill/>
+        </p:spPr>
+        <p:txBody>
+          <a:bodyPr wrap="square" lIns="91440" tIns="45720" rIns="91440" bIns="45720">
+            <a:spAutoFit/>
+          </a:bodyPr>
+          <a:lstStyle/>
+          <a:p>
+            <a:pPr algn="ctr"/>
+            <a:r>
+              <a:rPr lang="es-ES" sz="800" dirty="0">
+                <a:ln w="0"/>
+                <a:effectLst>
+                  <a:outerShdw blurRad="38100" dist="19050" dir="2700000" algn="tl" rotWithShape="0">
+                    <a:schemeClr val="dk1">
+                      <a:alpha val="40000"/>
+                    </a:schemeClr>
+                  </a:outerShdw>
+                </a:effectLst>
+              </a:rPr>
+              <a:t>Añadir ejercicio</a:t>
+            </a:r>
+            <a:endParaRPr lang="es-ES" sz="800" b="0" cap="none" spc="0" dirty="0">
+              <a:ln w="0"/>
+              <a:solidFill>
+                <a:schemeClr val="tx1"/>
+              </a:solidFill>
+              <a:effectLst>
+                <a:outerShdw blurRad="38100" dist="19050" dir="2700000" algn="tl" rotWithShape="0">
+                  <a:schemeClr val="dk1">
+                    <a:alpha val="40000"/>
+                  </a:schemeClr>
+                </a:outerShdw>
+              </a:effectLst>
+            </a:endParaRPr>
+          </a:p>
+        </p:txBody>
+      </p:sp>
+      <p:sp>
+        <p:nvSpPr>
+          <p:cNvPr id="1070" name="Rectángulo 1069">
+            <a:extLst>
+              <a:ext uri="{FF2B5EF4-FFF2-40B4-BE49-F238E27FC236}">
+                <a16:creationId xmlns:a16="http://schemas.microsoft.com/office/drawing/2014/main" id="{2FE18C1C-DA5A-CC16-0F29-DFBF19BC69B2}"/>
+              </a:ext>
+            </a:extLst>
+          </p:cNvPr>
+          <p:cNvSpPr/>
+          <p:nvPr/>
+        </p:nvSpPr>
+        <p:spPr>
+          <a:xfrm>
+            <a:off x="-1621579" y="3892568"/>
+            <a:ext cx="1438199" cy="184666"/>
+          </a:xfrm>
+          <a:prstGeom prst="rect">
+            <a:avLst/>
+          </a:prstGeom>
+          <a:noFill/>
+        </p:spPr>
+        <p:txBody>
+          <a:bodyPr wrap="square" lIns="91440" tIns="45720" rIns="91440" bIns="45720">
+            <a:spAutoFit/>
+          </a:bodyPr>
+          <a:lstStyle/>
+          <a:p>
+            <a:r>
+              <a:rPr lang="es-ES" sz="600" dirty="0">
+                <a:ln w="0"/>
+                <a:effectLst>
+                  <a:outerShdw blurRad="38100" dist="19050" dir="2700000" algn="tl" rotWithShape="0">
+                    <a:schemeClr val="dk1">
+                      <a:alpha val="40000"/>
+                    </a:schemeClr>
+                  </a:outerShdw>
+                </a:effectLst>
+              </a:rPr>
+              <a:t>Nombre:</a:t>
+            </a:r>
+            <a:endParaRPr lang="es-ES" sz="600" b="0" cap="none" spc="0" dirty="0">
+              <a:ln w="0"/>
+              <a:solidFill>
+                <a:schemeClr val="tx1"/>
+              </a:solidFill>
+              <a:effectLst>
+                <a:outerShdw blurRad="38100" dist="19050" dir="2700000" algn="tl" rotWithShape="0">
+                  <a:schemeClr val="dk1">
+                    <a:alpha val="40000"/>
+                  </a:schemeClr>
+                </a:outerShdw>
+              </a:effectLst>
+            </a:endParaRPr>
+          </a:p>
+        </p:txBody>
+      </p:sp>
+      <p:sp>
+        <p:nvSpPr>
+          <p:cNvPr id="1071" name="Rectángulo 1070">
+            <a:extLst>
+              <a:ext uri="{FF2B5EF4-FFF2-40B4-BE49-F238E27FC236}">
+                <a16:creationId xmlns:a16="http://schemas.microsoft.com/office/drawing/2014/main" id="{DE956117-0AE2-4CAB-FF42-86D4C739D0F1}"/>
+              </a:ext>
+            </a:extLst>
+          </p:cNvPr>
+          <p:cNvSpPr/>
+          <p:nvPr/>
+        </p:nvSpPr>
+        <p:spPr>
+          <a:xfrm>
+            <a:off x="-1526248" y="4050239"/>
+            <a:ext cx="1255298" cy="106357"/>
+          </a:xfrm>
+          <a:prstGeom prst="rect">
+            <a:avLst/>
+          </a:prstGeom>
+          <a:solidFill>
+            <a:schemeClr val="bg1"/>
+          </a:solidFill>
+          <a:ln w="6350">
+            <a:solidFill>
+              <a:schemeClr val="tx1"/>
+            </a:solidFill>
+          </a:ln>
+        </p:spPr>
+        <p:style>
+          <a:lnRef idx="2">
+            <a:schemeClr val="accent1">
+              <a:shade val="15000"/>
+            </a:schemeClr>
+          </a:lnRef>
+          <a:fillRef idx="1">
+            <a:schemeClr val="accent1"/>
+          </a:fillRef>
+          <a:effectRef idx="0">
+            <a:schemeClr val="accent1"/>
+          </a:effectRef>
+          <a:fontRef idx="minor">
+            <a:schemeClr val="lt1"/>
+          </a:fontRef>
+        </p:style>
+        <p:txBody>
+          <a:bodyPr rtlCol="0" anchor="ctr"/>
+          <a:lstStyle/>
+          <a:p>
+            <a:r>
+              <a:rPr lang="es-MX" sz="600" dirty="0">
+                <a:solidFill>
+                  <a:schemeClr val="tx1"/>
+                </a:solidFill>
+              </a:rPr>
+              <a:t>Peso muerto</a:t>
+            </a:r>
+          </a:p>
+        </p:txBody>
+      </p:sp>
+      <p:sp>
+        <p:nvSpPr>
+          <p:cNvPr id="1072" name="Rectángulo 1071">
+            <a:extLst>
+              <a:ext uri="{FF2B5EF4-FFF2-40B4-BE49-F238E27FC236}">
+                <a16:creationId xmlns:a16="http://schemas.microsoft.com/office/drawing/2014/main" id="{92EDC502-9584-C83B-4A02-81BA101B958A}"/>
+              </a:ext>
+            </a:extLst>
+          </p:cNvPr>
+          <p:cNvSpPr/>
+          <p:nvPr/>
+        </p:nvSpPr>
+        <p:spPr>
+          <a:xfrm>
+            <a:off x="-1621579" y="4149875"/>
+            <a:ext cx="1438199" cy="184666"/>
+          </a:xfrm>
+          <a:prstGeom prst="rect">
+            <a:avLst/>
+          </a:prstGeom>
+          <a:noFill/>
+        </p:spPr>
+        <p:txBody>
+          <a:bodyPr wrap="square" lIns="91440" tIns="45720" rIns="91440" bIns="45720">
+            <a:spAutoFit/>
+          </a:bodyPr>
+          <a:lstStyle/>
+          <a:p>
+            <a:r>
+              <a:rPr lang="es-ES" sz="600" dirty="0">
+                <a:ln w="0"/>
+                <a:effectLst>
+                  <a:outerShdw blurRad="38100" dist="19050" dir="2700000" algn="tl" rotWithShape="0">
+                    <a:schemeClr val="dk1">
+                      <a:alpha val="40000"/>
+                    </a:schemeClr>
+                  </a:outerShdw>
+                </a:effectLst>
+              </a:rPr>
+              <a:t>Imagen:</a:t>
+            </a:r>
+            <a:endParaRPr lang="es-ES" sz="600" b="0" cap="none" spc="0" dirty="0">
+              <a:ln w="0"/>
+              <a:solidFill>
+                <a:schemeClr val="tx1"/>
+              </a:solidFill>
+              <a:effectLst>
+                <a:outerShdw blurRad="38100" dist="19050" dir="2700000" algn="tl" rotWithShape="0">
+                  <a:schemeClr val="dk1">
+                    <a:alpha val="40000"/>
+                  </a:schemeClr>
+                </a:outerShdw>
+              </a:effectLst>
+            </a:endParaRPr>
+          </a:p>
+        </p:txBody>
+      </p:sp>
+      <p:sp>
+        <p:nvSpPr>
+          <p:cNvPr id="1073" name="Rectángulo 1072">
+            <a:extLst>
+              <a:ext uri="{FF2B5EF4-FFF2-40B4-BE49-F238E27FC236}">
+                <a16:creationId xmlns:a16="http://schemas.microsoft.com/office/drawing/2014/main" id="{555B6E6C-11D9-A928-A9BD-5F3A3B0F5525}"/>
+              </a:ext>
+            </a:extLst>
+          </p:cNvPr>
+          <p:cNvSpPr/>
+          <p:nvPr/>
+        </p:nvSpPr>
+        <p:spPr>
+          <a:xfrm>
+            <a:off x="-1191082" y="4302343"/>
+            <a:ext cx="504000" cy="504000"/>
+          </a:xfrm>
+          <a:prstGeom prst="rect">
+            <a:avLst/>
+          </a:prstGeom>
+          <a:solidFill>
+            <a:schemeClr val="bg1"/>
+          </a:solidFill>
+          <a:ln w="9525">
+            <a:solidFill>
+              <a:schemeClr val="tx1"/>
+            </a:solidFill>
+          </a:ln>
+        </p:spPr>
+        <p:style>
+          <a:lnRef idx="2">
+            <a:schemeClr val="accent1">
+              <a:shade val="15000"/>
+            </a:schemeClr>
+          </a:lnRef>
+          <a:fillRef idx="1">
+            <a:schemeClr val="accent1"/>
+          </a:fillRef>
+          <a:effectRef idx="0">
+            <a:schemeClr val="accent1"/>
+          </a:effectRef>
+          <a:fontRef idx="minor">
+            <a:schemeClr val="lt1"/>
+          </a:fontRef>
+        </p:style>
+        <p:txBody>
+          <a:bodyPr rtlCol="0" anchor="ctr"/>
+          <a:lstStyle/>
+          <a:p>
+            <a:pPr algn="ctr"/>
+            <a:r>
+              <a:rPr lang="es-MX" sz="2800" dirty="0">
+                <a:solidFill>
+                  <a:schemeClr val="tx1"/>
+                </a:solidFill>
+              </a:rPr>
+              <a:t>+</a:t>
+            </a:r>
+          </a:p>
+        </p:txBody>
+      </p:sp>
+      <p:sp>
+        <p:nvSpPr>
+          <p:cNvPr id="1074" name="Rectángulo 1073">
+            <a:extLst>
+              <a:ext uri="{FF2B5EF4-FFF2-40B4-BE49-F238E27FC236}">
+                <a16:creationId xmlns:a16="http://schemas.microsoft.com/office/drawing/2014/main" id="{47D97F6C-1108-3E26-9D1A-D1ECCD709D68}"/>
+              </a:ext>
+            </a:extLst>
+          </p:cNvPr>
+          <p:cNvSpPr/>
+          <p:nvPr/>
+        </p:nvSpPr>
+        <p:spPr>
+          <a:xfrm>
+            <a:off x="-1621579" y="4814339"/>
+            <a:ext cx="1438199" cy="184666"/>
+          </a:xfrm>
+          <a:prstGeom prst="rect">
+            <a:avLst/>
+          </a:prstGeom>
+          <a:noFill/>
+        </p:spPr>
+        <p:txBody>
+          <a:bodyPr wrap="square" lIns="91440" tIns="45720" rIns="91440" bIns="45720">
+            <a:spAutoFit/>
+          </a:bodyPr>
+          <a:lstStyle/>
+          <a:p>
+            <a:r>
+              <a:rPr lang="es-ES" sz="600" dirty="0">
+                <a:ln w="0"/>
+                <a:effectLst>
+                  <a:outerShdw blurRad="38100" dist="19050" dir="2700000" algn="tl" rotWithShape="0">
+                    <a:schemeClr val="dk1">
+                      <a:alpha val="40000"/>
+                    </a:schemeClr>
+                  </a:outerShdw>
+                </a:effectLst>
+              </a:rPr>
+              <a:t>Grupo muscular:</a:t>
+            </a:r>
+            <a:endParaRPr lang="es-ES" sz="600" b="0" cap="none" spc="0" dirty="0">
+              <a:ln w="0"/>
+              <a:solidFill>
+                <a:schemeClr val="tx1"/>
+              </a:solidFill>
+              <a:effectLst>
+                <a:outerShdw blurRad="38100" dist="19050" dir="2700000" algn="tl" rotWithShape="0">
+                  <a:schemeClr val="dk1">
+                    <a:alpha val="40000"/>
+                  </a:schemeClr>
+                </a:outerShdw>
+              </a:effectLst>
+            </a:endParaRPr>
+          </a:p>
+        </p:txBody>
+      </p:sp>
+      <p:sp>
+        <p:nvSpPr>
+          <p:cNvPr id="1075" name="Rectángulo 1074">
+            <a:extLst>
+              <a:ext uri="{FF2B5EF4-FFF2-40B4-BE49-F238E27FC236}">
+                <a16:creationId xmlns:a16="http://schemas.microsoft.com/office/drawing/2014/main" id="{594073A8-9EDC-7457-F4E5-3D3C54DA55E5}"/>
+              </a:ext>
+            </a:extLst>
+          </p:cNvPr>
+          <p:cNvSpPr/>
+          <p:nvPr/>
+        </p:nvSpPr>
+        <p:spPr>
+          <a:xfrm>
+            <a:off x="-1505479" y="5501755"/>
+            <a:ext cx="1322100" cy="184666"/>
+          </a:xfrm>
+          <a:prstGeom prst="rect">
+            <a:avLst/>
+          </a:prstGeom>
+          <a:noFill/>
+        </p:spPr>
+        <p:txBody>
+          <a:bodyPr wrap="square" lIns="91440" tIns="45720" rIns="91440" bIns="45720">
+            <a:spAutoFit/>
+          </a:bodyPr>
+          <a:lstStyle/>
+          <a:p>
+            <a:r>
+              <a:rPr lang="es-ES" sz="600" dirty="0">
+                <a:ln w="0"/>
+                <a:effectLst>
+                  <a:outerShdw blurRad="38100" dist="19050" dir="2700000" algn="tl" rotWithShape="0">
+                    <a:schemeClr val="dk1">
+                      <a:alpha val="40000"/>
+                    </a:schemeClr>
+                  </a:outerShdw>
+                </a:effectLst>
+              </a:rPr>
+              <a:t>Añadir</a:t>
+            </a:r>
+            <a:endParaRPr lang="es-ES" sz="600" b="0" cap="none" spc="0" dirty="0">
+              <a:ln w="0"/>
+              <a:solidFill>
+                <a:schemeClr val="tx1"/>
+              </a:solidFill>
+              <a:effectLst>
+                <a:outerShdw blurRad="38100" dist="19050" dir="2700000" algn="tl" rotWithShape="0">
+                  <a:schemeClr val="dk1">
+                    <a:alpha val="40000"/>
+                  </a:schemeClr>
+                </a:outerShdw>
+              </a:effectLst>
+            </a:endParaRPr>
+          </a:p>
+        </p:txBody>
+      </p:sp>
+      <p:pic>
+        <p:nvPicPr>
+          <p:cNvPr id="1076" name="Picture 2" descr="Ilustración De Diseño De Icono De Vector De Disquete PNG ,dibujos Disco  Flexible, Disco Flash, Disquete PNG y Vector para Descargar Gratis | Pngtree">
+            <a:extLst>
+              <a:ext uri="{FF2B5EF4-FFF2-40B4-BE49-F238E27FC236}">
+                <a16:creationId xmlns:a16="http://schemas.microsoft.com/office/drawing/2014/main" id="{98A1B102-427B-5590-6891-12A4F17C0827}"/>
+              </a:ext>
+            </a:extLst>
+          </p:cNvPr>
+          <p:cNvPicPr>
+            <a:picLocks noChangeAspect="1" noChangeArrowheads="1"/>
+          </p:cNvPicPr>
+          <p:nvPr/>
+        </p:nvPicPr>
+        <p:blipFill>
+          <a:blip r:embed="rId9">
+            <a:extLst>
+              <a:ext uri="{28A0092B-C50C-407E-A947-70E740481C1C}">
+                <a14:useLocalDpi xmlns:a14="http://schemas.microsoft.com/office/drawing/2010/main" val="0"/>
+              </a:ext>
+            </a:extLst>
+          </a:blip>
+          <a:srcRect/>
+          <a:stretch>
+            <a:fillRect/>
+          </a:stretch>
+        </p:blipFill>
+        <p:spPr bwMode="auto">
+          <a:xfrm>
+            <a:off x="-419895" y="3726309"/>
+            <a:ext cx="144000" cy="144000"/>
+          </a:xfrm>
+          <a:prstGeom prst="rect">
+            <a:avLst/>
+          </a:prstGeom>
+          <a:noFill/>
+          <a:extLst>
+            <a:ext uri="{909E8E84-426E-40DD-AFC4-6F175D3DCCD1}">
+              <a14:hiddenFill xmlns:a14="http://schemas.microsoft.com/office/drawing/2010/main">
+                <a:solidFill>
+                  <a:srgbClr val="FFFFFF"/>
+                </a:solidFill>
+              </a14:hiddenFill>
+            </a:ext>
+          </a:extLst>
+        </p:spPr>
+      </p:pic>
+      <p:pic>
+        <p:nvPicPr>
+          <p:cNvPr id="1077" name="Imagen 1076">
+            <a:extLst>
+              <a:ext uri="{FF2B5EF4-FFF2-40B4-BE49-F238E27FC236}">
+                <a16:creationId xmlns:a16="http://schemas.microsoft.com/office/drawing/2014/main" id="{154591BE-69A5-0E73-EA2F-47BA507BE59F}"/>
+              </a:ext>
+            </a:extLst>
+          </p:cNvPr>
+          <p:cNvPicPr>
+            <a:picLocks noChangeAspect="1"/>
+          </p:cNvPicPr>
+          <p:nvPr/>
+        </p:nvPicPr>
+        <p:blipFill>
+          <a:blip r:embed="rId10">
+            <a:clrChange>
+              <a:clrFrom>
+                <a:srgbClr val="FFFFFF"/>
+              </a:clrFrom>
+              <a:clrTo>
+                <a:srgbClr val="FFFFFF">
+                  <a:alpha val="0"/>
+                </a:srgbClr>
+              </a:clrTo>
+            </a:clrChange>
+          </a:blip>
+          <a:stretch>
+            <a:fillRect/>
+          </a:stretch>
+        </p:blipFill>
+        <p:spPr>
+          <a:xfrm>
+            <a:off x="-1520916" y="3716527"/>
+            <a:ext cx="132857" cy="144000"/>
+          </a:xfrm>
+          <a:prstGeom prst="rect">
+            <a:avLst/>
+          </a:prstGeom>
+        </p:spPr>
+      </p:pic>
+      <p:pic>
+        <p:nvPicPr>
+          <p:cNvPr id="1053" name="Picture 4" descr="317,500+ Gym Workout Male Stock Photos, Pictures &amp; Royalty-Free Images -  iStock">
+            <a:extLst>
+              <a:ext uri="{FF2B5EF4-FFF2-40B4-BE49-F238E27FC236}">
+                <a16:creationId xmlns:a16="http://schemas.microsoft.com/office/drawing/2014/main" id="{93390256-5E53-5BCE-2880-7A1068A0688A}"/>
+              </a:ext>
+            </a:extLst>
+          </p:cNvPr>
+          <p:cNvPicPr>
+            <a:picLocks noChangeAspect="1" noChangeArrowheads="1"/>
+          </p:cNvPicPr>
+          <p:nvPr/>
+        </p:nvPicPr>
+        <p:blipFill rotWithShape="1">
+          <a:blip r:embed="rId3">
+            <a:extLst>
+              <a:ext uri="{28A0092B-C50C-407E-A947-70E740481C1C}">
+                <a14:useLocalDpi xmlns:a14="http://schemas.microsoft.com/office/drawing/2010/main" val="0"/>
+              </a:ext>
+            </a:extLst>
+          </a:blip>
+          <a:srcRect t="7027" b="26307"/>
+          <a:stretch/>
+        </p:blipFill>
+        <p:spPr bwMode="auto">
+          <a:xfrm>
+            <a:off x="-1189600" y="4303809"/>
+            <a:ext cx="504000" cy="504000"/>
+          </a:xfrm>
+          <a:prstGeom prst="rect">
+            <a:avLst/>
+          </a:prstGeom>
+          <a:noFill/>
+          <a:extLst>
+            <a:ext uri="{909E8E84-426E-40DD-AFC4-6F175D3DCCD1}">
+              <a14:hiddenFill xmlns:a14="http://schemas.microsoft.com/office/drawing/2010/main">
+                <a:solidFill>
+                  <a:srgbClr val="FFFFFF"/>
+                </a:solidFill>
+              </a14:hiddenFill>
+            </a:ext>
+          </a:extLst>
+        </p:spPr>
+      </p:pic>
+      <p:sp>
+        <p:nvSpPr>
+          <p:cNvPr id="1078" name="Rectángulo 1077">
+            <a:extLst>
+              <a:ext uri="{FF2B5EF4-FFF2-40B4-BE49-F238E27FC236}">
+                <a16:creationId xmlns:a16="http://schemas.microsoft.com/office/drawing/2014/main" id="{FD5E4104-F7EC-45B2-39BF-F9E8EDF1EF1B}"/>
+              </a:ext>
+            </a:extLst>
+          </p:cNvPr>
+          <p:cNvSpPr/>
+          <p:nvPr/>
+        </p:nvSpPr>
+        <p:spPr>
+          <a:xfrm>
+            <a:off x="-106256" y="4354168"/>
+            <a:ext cx="478800" cy="184666"/>
+          </a:xfrm>
+          <a:prstGeom prst="rect">
+            <a:avLst/>
+          </a:prstGeom>
+          <a:noFill/>
+        </p:spPr>
+        <p:txBody>
+          <a:bodyPr wrap="square" lIns="91440" tIns="45720" rIns="91440" bIns="45720">
+            <a:spAutoFit/>
+          </a:bodyPr>
+          <a:lstStyle/>
+          <a:p>
+            <a:pPr algn="ctr"/>
+            <a:r>
+              <a:rPr lang="es-ES" sz="600" b="0" cap="none" spc="0" dirty="0">
+                <a:ln w="0"/>
+                <a:solidFill>
+                  <a:schemeClr val="tx1"/>
+                </a:solidFill>
+                <a:effectLst>
+                  <a:outerShdw blurRad="38100" dist="19050" dir="2700000" algn="tl" rotWithShape="0">
+                    <a:schemeClr val="dk1">
+                      <a:alpha val="40000"/>
+                    </a:schemeClr>
+                  </a:outerShdw>
+                </a:effectLst>
+              </a:rPr>
+              <a:t>Ejemplo</a:t>
+            </a:r>
+          </a:p>
+        </p:txBody>
+      </p:sp>
+      <p:sp>
+        <p:nvSpPr>
+          <p:cNvPr id="1079" name="Elipse 1078">
+            <a:extLst>
+              <a:ext uri="{FF2B5EF4-FFF2-40B4-BE49-F238E27FC236}">
+                <a16:creationId xmlns:a16="http://schemas.microsoft.com/office/drawing/2014/main" id="{44E4FE94-6F3B-A46F-1AE6-EEC1B1F9E992}"/>
+              </a:ext>
+            </a:extLst>
+          </p:cNvPr>
+          <p:cNvSpPr/>
+          <p:nvPr/>
+        </p:nvSpPr>
+        <p:spPr>
+          <a:xfrm>
+            <a:off x="-1551260" y="5536163"/>
+            <a:ext cx="108000" cy="108000"/>
+          </a:xfrm>
+          <a:prstGeom prst="ellipse">
+            <a:avLst/>
+          </a:prstGeom>
+          <a:noFill/>
+          <a:ln w="6350">
+            <a:solidFill>
+              <a:schemeClr val="tx1"/>
+            </a:solidFill>
+          </a:ln>
+        </p:spPr>
+        <p:style>
+          <a:lnRef idx="2">
+            <a:schemeClr val="accent1">
+              <a:shade val="15000"/>
+            </a:schemeClr>
+          </a:lnRef>
+          <a:fillRef idx="1">
+            <a:schemeClr val="accent1"/>
+          </a:fillRef>
+          <a:effectRef idx="0">
+            <a:schemeClr val="accent1"/>
+          </a:effectRef>
+          <a:fontRef idx="minor">
+            <a:schemeClr val="lt1"/>
+          </a:fontRef>
+        </p:style>
+        <p:txBody>
+          <a:bodyPr rtlCol="0" anchor="ctr"/>
+          <a:lstStyle/>
+          <a:p>
+            <a:pPr algn="ctr"/>
+            <a:r>
+              <a:rPr lang="es-MX" sz="1000" dirty="0">
+                <a:solidFill>
+                  <a:schemeClr val="tx1"/>
+                </a:solidFill>
+              </a:rPr>
+              <a:t>+</a:t>
+            </a:r>
+          </a:p>
+        </p:txBody>
+      </p:sp>
+      <p:pic>
+        <p:nvPicPr>
+          <p:cNvPr id="1080" name="Picture 14" descr="edit Vector Icons free download in SVG, PNG Format">
+            <a:extLst>
+              <a:ext uri="{FF2B5EF4-FFF2-40B4-BE49-F238E27FC236}">
+                <a16:creationId xmlns:a16="http://schemas.microsoft.com/office/drawing/2014/main" id="{3561FA69-1061-A605-C368-4D1BF9E9DE43}"/>
+              </a:ext>
+            </a:extLst>
+          </p:cNvPr>
+          <p:cNvPicPr>
+            <a:picLocks noChangeAspect="1" noChangeArrowheads="1"/>
+          </p:cNvPicPr>
+          <p:nvPr/>
+        </p:nvPicPr>
+        <p:blipFill>
+          <a:blip r:embed="rId11">
+            <a:extLst>
+              <a:ext uri="{28A0092B-C50C-407E-A947-70E740481C1C}">
+                <a14:useLocalDpi xmlns:a14="http://schemas.microsoft.com/office/drawing/2010/main" val="0"/>
+              </a:ext>
+            </a:extLst>
+          </a:blip>
+          <a:srcRect/>
+          <a:stretch>
+            <a:fillRect/>
+          </a:stretch>
+        </p:blipFill>
+        <p:spPr bwMode="auto">
+          <a:xfrm>
+            <a:off x="-664237" y="4387976"/>
+            <a:ext cx="144000" cy="144000"/>
+          </a:xfrm>
+          <a:prstGeom prst="rect">
+            <a:avLst/>
+          </a:prstGeom>
+          <a:noFill/>
+          <a:extLst>
+            <a:ext uri="{909E8E84-426E-40DD-AFC4-6F175D3DCCD1}">
+              <a14:hiddenFill xmlns:a14="http://schemas.microsoft.com/office/drawing/2010/main">
+                <a:solidFill>
+                  <a:srgbClr val="FFFFFF"/>
+                </a:solidFill>
+              </a14:hiddenFill>
+            </a:ext>
+          </a:extLst>
+        </p:spPr>
+      </p:pic>
+      <p:pic>
+        <p:nvPicPr>
+          <p:cNvPr id="1081" name="Imagen 1080">
+            <a:extLst>
+              <a:ext uri="{FF2B5EF4-FFF2-40B4-BE49-F238E27FC236}">
+                <a16:creationId xmlns:a16="http://schemas.microsoft.com/office/drawing/2014/main" id="{F8785948-9C15-4756-BD41-4141B1652469}"/>
+              </a:ext>
+            </a:extLst>
+          </p:cNvPr>
+          <p:cNvPicPr>
+            <a:picLocks noChangeAspect="1"/>
+          </p:cNvPicPr>
+          <p:nvPr/>
+        </p:nvPicPr>
+        <p:blipFill>
+          <a:blip r:embed="rId10">
+            <a:clrChange>
+              <a:clrFrom>
+                <a:srgbClr val="FFFFFF"/>
+              </a:clrFrom>
+              <a:clrTo>
+                <a:srgbClr val="FFFFFF">
+                  <a:alpha val="0"/>
+                </a:srgbClr>
+              </a:clrTo>
+            </a:clrChange>
+          </a:blip>
+          <a:stretch>
+            <a:fillRect/>
+          </a:stretch>
+        </p:blipFill>
+        <p:spPr>
+          <a:xfrm>
+            <a:off x="-633522" y="4601293"/>
+            <a:ext cx="99643" cy="108000"/>
+          </a:xfrm>
+          <a:prstGeom prst="rect">
+            <a:avLst/>
+          </a:prstGeom>
+        </p:spPr>
+      </p:pic>
+      <p:sp>
+        <p:nvSpPr>
+          <p:cNvPr id="1082" name="Rectángulo: esquinas redondeadas 1081">
+            <a:extLst>
+              <a:ext uri="{FF2B5EF4-FFF2-40B4-BE49-F238E27FC236}">
+                <a16:creationId xmlns:a16="http://schemas.microsoft.com/office/drawing/2014/main" id="{8EB1580E-2436-01E6-76E5-CF865BF3203D}"/>
+              </a:ext>
+            </a:extLst>
+          </p:cNvPr>
+          <p:cNvSpPr/>
+          <p:nvPr/>
+        </p:nvSpPr>
+        <p:spPr>
+          <a:xfrm>
+            <a:off x="-1539806" y="4969634"/>
+            <a:ext cx="458867" cy="172734"/>
+          </a:xfrm>
+          <a:prstGeom prst="roundRect">
+            <a:avLst>
+              <a:gd name="adj" fmla="val 49020"/>
+            </a:avLst>
+          </a:prstGeom>
+          <a:solidFill>
+            <a:srgbClr val="FFC000"/>
+          </a:solidFill>
+          <a:ln>
+            <a:noFill/>
+          </a:ln>
+        </p:spPr>
+        <p:style>
+          <a:lnRef idx="2">
+            <a:schemeClr val="accent1">
+              <a:shade val="15000"/>
+            </a:schemeClr>
+          </a:lnRef>
+          <a:fillRef idx="1">
+            <a:schemeClr val="accent1"/>
+          </a:fillRef>
+          <a:effectRef idx="0">
+            <a:schemeClr val="accent1"/>
+          </a:effectRef>
+          <a:fontRef idx="minor">
+            <a:schemeClr val="lt1"/>
+          </a:fontRef>
+        </p:style>
+        <p:txBody>
+          <a:bodyPr rtlCol="0" anchor="ctr"/>
+          <a:lstStyle/>
+          <a:p>
+            <a:pPr algn="ctr"/>
+            <a:r>
+              <a:rPr lang="es-MX" sz="500" dirty="0">
+                <a:solidFill>
+                  <a:schemeClr val="tx1"/>
+                </a:solidFill>
+              </a:rPr>
+              <a:t>Bíceps</a:t>
+            </a:r>
+          </a:p>
+        </p:txBody>
+      </p:sp>
+      <p:sp>
+        <p:nvSpPr>
+          <p:cNvPr id="1083" name="Rectángulo: esquinas redondeadas 1082">
+            <a:extLst>
+              <a:ext uri="{FF2B5EF4-FFF2-40B4-BE49-F238E27FC236}">
+                <a16:creationId xmlns:a16="http://schemas.microsoft.com/office/drawing/2014/main" id="{B4A5A064-5C9E-A8E1-42DF-4892741B3C02}"/>
+              </a:ext>
+            </a:extLst>
+          </p:cNvPr>
+          <p:cNvSpPr/>
+          <p:nvPr/>
+        </p:nvSpPr>
+        <p:spPr>
+          <a:xfrm>
+            <a:off x="-1544527" y="5160669"/>
+            <a:ext cx="458867" cy="172734"/>
+          </a:xfrm>
+          <a:prstGeom prst="roundRect">
+            <a:avLst>
+              <a:gd name="adj" fmla="val 49020"/>
+            </a:avLst>
+          </a:prstGeom>
+          <a:solidFill>
+            <a:srgbClr val="FFC000"/>
+          </a:solidFill>
+          <a:ln>
+            <a:noFill/>
+          </a:ln>
+        </p:spPr>
+        <p:style>
+          <a:lnRef idx="2">
+            <a:schemeClr val="accent1">
+              <a:shade val="15000"/>
+            </a:schemeClr>
+          </a:lnRef>
+          <a:fillRef idx="1">
+            <a:schemeClr val="accent1"/>
+          </a:fillRef>
+          <a:effectRef idx="0">
+            <a:schemeClr val="accent1"/>
+          </a:effectRef>
+          <a:fontRef idx="minor">
+            <a:schemeClr val="lt1"/>
+          </a:fontRef>
+        </p:style>
+        <p:txBody>
+          <a:bodyPr rtlCol="0" anchor="ctr"/>
+          <a:lstStyle/>
+          <a:p>
+            <a:pPr algn="ctr"/>
+            <a:r>
+              <a:rPr lang="es-MX" sz="500" dirty="0">
+                <a:solidFill>
+                  <a:schemeClr val="tx1"/>
+                </a:solidFill>
+              </a:rPr>
+              <a:t>Tríceps</a:t>
+            </a:r>
+          </a:p>
+        </p:txBody>
+      </p:sp>
+      <p:pic>
+        <p:nvPicPr>
+          <p:cNvPr id="1084" name="Picture 14" descr="edit Vector Icons free download in SVG, PNG Format">
+            <a:extLst>
+              <a:ext uri="{FF2B5EF4-FFF2-40B4-BE49-F238E27FC236}">
+                <a16:creationId xmlns:a16="http://schemas.microsoft.com/office/drawing/2014/main" id="{1E16FB34-37DF-6059-F46B-AD18E12286CD}"/>
+              </a:ext>
+            </a:extLst>
+          </p:cNvPr>
+          <p:cNvPicPr>
+            <a:picLocks noChangeAspect="1" noChangeArrowheads="1"/>
+          </p:cNvPicPr>
+          <p:nvPr/>
+        </p:nvPicPr>
+        <p:blipFill>
+          <a:blip r:embed="rId11">
+            <a:extLst>
+              <a:ext uri="{28A0092B-C50C-407E-A947-70E740481C1C}">
+                <a14:useLocalDpi xmlns:a14="http://schemas.microsoft.com/office/drawing/2010/main" val="0"/>
+              </a:ext>
+            </a:extLst>
+          </a:blip>
+          <a:srcRect/>
+          <a:stretch>
+            <a:fillRect/>
+          </a:stretch>
+        </p:blipFill>
+        <p:spPr bwMode="auto">
+          <a:xfrm>
+            <a:off x="-622610" y="4980833"/>
+            <a:ext cx="144000" cy="144000"/>
+          </a:xfrm>
+          <a:prstGeom prst="rect">
+            <a:avLst/>
+          </a:prstGeom>
+          <a:noFill/>
+          <a:extLst>
+            <a:ext uri="{909E8E84-426E-40DD-AFC4-6F175D3DCCD1}">
+              <a14:hiddenFill xmlns:a14="http://schemas.microsoft.com/office/drawing/2010/main">
+                <a:solidFill>
+                  <a:srgbClr val="FFFFFF"/>
+                </a:solidFill>
+              </a14:hiddenFill>
+            </a:ext>
+          </a:extLst>
+        </p:spPr>
+      </p:pic>
+      <p:pic>
+        <p:nvPicPr>
+          <p:cNvPr id="1085" name="Imagen 1084">
+            <a:extLst>
+              <a:ext uri="{FF2B5EF4-FFF2-40B4-BE49-F238E27FC236}">
+                <a16:creationId xmlns:a16="http://schemas.microsoft.com/office/drawing/2014/main" id="{CFB6BDC1-D08A-FBDD-2965-ECC3A80B81D3}"/>
+              </a:ext>
+            </a:extLst>
+          </p:cNvPr>
+          <p:cNvPicPr>
+            <a:picLocks noChangeAspect="1"/>
+          </p:cNvPicPr>
+          <p:nvPr/>
+        </p:nvPicPr>
+        <p:blipFill>
+          <a:blip r:embed="rId10">
+            <a:clrChange>
+              <a:clrFrom>
+                <a:srgbClr val="FFFFFF"/>
+              </a:clrFrom>
+              <a:clrTo>
+                <a:srgbClr val="FFFFFF">
+                  <a:alpha val="0"/>
+                </a:srgbClr>
+              </a:clrTo>
+            </a:clrChange>
+          </a:blip>
+          <a:stretch>
+            <a:fillRect/>
+          </a:stretch>
+        </p:blipFill>
+        <p:spPr>
+          <a:xfrm>
+            <a:off x="-445075" y="5006118"/>
+            <a:ext cx="99643" cy="108000"/>
+          </a:xfrm>
+          <a:prstGeom prst="rect">
+            <a:avLst/>
+          </a:prstGeom>
+        </p:spPr>
+      </p:pic>
+      <p:pic>
+        <p:nvPicPr>
+          <p:cNvPr id="1086" name="Picture 14" descr="edit Vector Icons free download in SVG, PNG Format">
+            <a:extLst>
+              <a:ext uri="{FF2B5EF4-FFF2-40B4-BE49-F238E27FC236}">
+                <a16:creationId xmlns:a16="http://schemas.microsoft.com/office/drawing/2014/main" id="{E2881DF5-97DB-E93E-FA30-C42165E090ED}"/>
+              </a:ext>
+            </a:extLst>
+          </p:cNvPr>
+          <p:cNvPicPr>
+            <a:picLocks noChangeAspect="1" noChangeArrowheads="1"/>
+          </p:cNvPicPr>
+          <p:nvPr/>
+        </p:nvPicPr>
+        <p:blipFill>
+          <a:blip r:embed="rId11">
+            <a:extLst>
+              <a:ext uri="{28A0092B-C50C-407E-A947-70E740481C1C}">
+                <a14:useLocalDpi xmlns:a14="http://schemas.microsoft.com/office/drawing/2010/main" val="0"/>
+              </a:ext>
+            </a:extLst>
+          </a:blip>
+          <a:srcRect/>
+          <a:stretch>
+            <a:fillRect/>
+          </a:stretch>
+        </p:blipFill>
+        <p:spPr bwMode="auto">
+          <a:xfrm>
+            <a:off x="-619605" y="5164141"/>
+            <a:ext cx="144000" cy="144000"/>
+          </a:xfrm>
+          <a:prstGeom prst="rect">
+            <a:avLst/>
+          </a:prstGeom>
+          <a:noFill/>
+          <a:extLst>
+            <a:ext uri="{909E8E84-426E-40DD-AFC4-6F175D3DCCD1}">
+              <a14:hiddenFill xmlns:a14="http://schemas.microsoft.com/office/drawing/2010/main">
+                <a:solidFill>
+                  <a:srgbClr val="FFFFFF"/>
+                </a:solidFill>
+              </a14:hiddenFill>
+            </a:ext>
+          </a:extLst>
+        </p:spPr>
+      </p:pic>
+      <p:pic>
+        <p:nvPicPr>
+          <p:cNvPr id="1087" name="Imagen 1086">
+            <a:extLst>
+              <a:ext uri="{FF2B5EF4-FFF2-40B4-BE49-F238E27FC236}">
+                <a16:creationId xmlns:a16="http://schemas.microsoft.com/office/drawing/2014/main" id="{6A1672A8-C680-957C-3EB1-C9C26D5911CF}"/>
+              </a:ext>
+            </a:extLst>
+          </p:cNvPr>
+          <p:cNvPicPr>
+            <a:picLocks noChangeAspect="1"/>
+          </p:cNvPicPr>
+          <p:nvPr/>
+        </p:nvPicPr>
+        <p:blipFill>
+          <a:blip r:embed="rId10">
+            <a:clrChange>
+              <a:clrFrom>
+                <a:srgbClr val="FFFFFF"/>
+              </a:clrFrom>
+              <a:clrTo>
+                <a:srgbClr val="FFFFFF">
+                  <a:alpha val="0"/>
+                </a:srgbClr>
+              </a:clrTo>
+            </a:clrChange>
+          </a:blip>
+          <a:stretch>
+            <a:fillRect/>
+          </a:stretch>
+        </p:blipFill>
+        <p:spPr>
+          <a:xfrm>
+            <a:off x="-442070" y="5189426"/>
+            <a:ext cx="99643" cy="108000"/>
+          </a:xfrm>
+          <a:prstGeom prst="rect">
+            <a:avLst/>
+          </a:prstGeom>
+        </p:spPr>
+      </p:pic>
+      <p:sp>
+        <p:nvSpPr>
+          <p:cNvPr id="1088" name="Rectángulo: esquinas redondeadas 1087">
+            <a:extLst>
+              <a:ext uri="{FF2B5EF4-FFF2-40B4-BE49-F238E27FC236}">
+                <a16:creationId xmlns:a16="http://schemas.microsoft.com/office/drawing/2014/main" id="{39AB4170-0B9F-476D-6B0A-AD9B6D201C56}"/>
+              </a:ext>
+            </a:extLst>
+          </p:cNvPr>
+          <p:cNvSpPr/>
+          <p:nvPr/>
+        </p:nvSpPr>
+        <p:spPr>
+          <a:xfrm>
+            <a:off x="-1541522" y="5356858"/>
+            <a:ext cx="458867" cy="172734"/>
+          </a:xfrm>
+          <a:prstGeom prst="roundRect">
+            <a:avLst>
+              <a:gd name="adj" fmla="val 49020"/>
+            </a:avLst>
+          </a:prstGeom>
+          <a:solidFill>
+            <a:schemeClr val="bg1"/>
+          </a:solidFill>
+          <a:ln>
+            <a:solidFill>
+              <a:srgbClr val="FFC000"/>
+            </a:solidFill>
+          </a:ln>
+        </p:spPr>
+        <p:style>
+          <a:lnRef idx="2">
+            <a:schemeClr val="accent1">
+              <a:shade val="15000"/>
+            </a:schemeClr>
+          </a:lnRef>
+          <a:fillRef idx="1">
+            <a:schemeClr val="accent1"/>
+          </a:fillRef>
+          <a:effectRef idx="0">
+            <a:schemeClr val="accent1"/>
+          </a:effectRef>
+          <a:fontRef idx="minor">
+            <a:schemeClr val="lt1"/>
+          </a:fontRef>
+        </p:style>
+        <p:txBody>
+          <a:bodyPr rtlCol="0" anchor="ctr"/>
+          <a:lstStyle/>
+          <a:p>
+            <a:pPr algn="ctr"/>
+            <a:r>
+              <a:rPr lang="es-MX" sz="500" dirty="0">
+                <a:solidFill>
+                  <a:schemeClr val="tx1"/>
+                </a:solidFill>
+              </a:rPr>
+              <a:t>Tríceps</a:t>
+            </a:r>
+          </a:p>
+        </p:txBody>
+      </p:sp>
+      <p:pic>
+        <p:nvPicPr>
+          <p:cNvPr id="1089" name="Picture 14" descr="edit Vector Icons free download in SVG, PNG Format">
+            <a:extLst>
+              <a:ext uri="{FF2B5EF4-FFF2-40B4-BE49-F238E27FC236}">
+                <a16:creationId xmlns:a16="http://schemas.microsoft.com/office/drawing/2014/main" id="{D7E531F1-4D94-FDAD-838B-D3B5FAD07754}"/>
+              </a:ext>
+            </a:extLst>
+          </p:cNvPr>
+          <p:cNvPicPr>
+            <a:picLocks noChangeAspect="1" noChangeArrowheads="1"/>
+          </p:cNvPicPr>
+          <p:nvPr/>
+        </p:nvPicPr>
+        <p:blipFill>
+          <a:blip r:embed="rId11">
+            <a:extLst>
+              <a:ext uri="{28A0092B-C50C-407E-A947-70E740481C1C}">
+                <a14:useLocalDpi xmlns:a14="http://schemas.microsoft.com/office/drawing/2010/main" val="0"/>
+              </a:ext>
+            </a:extLst>
+          </a:blip>
+          <a:srcRect/>
+          <a:stretch>
+            <a:fillRect/>
+          </a:stretch>
+        </p:blipFill>
+        <p:spPr bwMode="auto">
+          <a:xfrm>
+            <a:off x="-616600" y="5360330"/>
+            <a:ext cx="144000" cy="144000"/>
+          </a:xfrm>
+          <a:prstGeom prst="rect">
+            <a:avLst/>
+          </a:prstGeom>
+          <a:noFill/>
+          <a:extLst>
+            <a:ext uri="{909E8E84-426E-40DD-AFC4-6F175D3DCCD1}">
+              <a14:hiddenFill xmlns:a14="http://schemas.microsoft.com/office/drawing/2010/main">
+                <a:solidFill>
+                  <a:srgbClr val="FFFFFF"/>
+                </a:solidFill>
+              </a14:hiddenFill>
+            </a:ext>
+          </a:extLst>
+        </p:spPr>
+      </p:pic>
+      <p:pic>
+        <p:nvPicPr>
+          <p:cNvPr id="1090" name="Imagen 1089">
+            <a:extLst>
+              <a:ext uri="{FF2B5EF4-FFF2-40B4-BE49-F238E27FC236}">
+                <a16:creationId xmlns:a16="http://schemas.microsoft.com/office/drawing/2014/main" id="{921CD076-B1EE-94B7-58C0-8F7A7990A40B}"/>
+              </a:ext>
+            </a:extLst>
+          </p:cNvPr>
+          <p:cNvPicPr>
+            <a:picLocks noChangeAspect="1"/>
+          </p:cNvPicPr>
+          <p:nvPr/>
+        </p:nvPicPr>
+        <p:blipFill>
+          <a:blip r:embed="rId10">
+            <a:clrChange>
+              <a:clrFrom>
+                <a:srgbClr val="FFFFFF"/>
+              </a:clrFrom>
+              <a:clrTo>
+                <a:srgbClr val="FFFFFF">
+                  <a:alpha val="0"/>
+                </a:srgbClr>
+              </a:clrTo>
+            </a:clrChange>
+          </a:blip>
+          <a:stretch>
+            <a:fillRect/>
+          </a:stretch>
+        </p:blipFill>
+        <p:spPr>
+          <a:xfrm>
+            <a:off x="-439065" y="5385615"/>
+            <a:ext cx="99643" cy="108000"/>
+          </a:xfrm>
+          <a:prstGeom prst="rect">
+            <a:avLst/>
+          </a:prstGeom>
+        </p:spPr>
+      </p:pic>
+      <p:cxnSp>
+        <p:nvCxnSpPr>
+          <p:cNvPr id="1091" name="Conector: curvado 1090">
+            <a:extLst>
+              <a:ext uri="{FF2B5EF4-FFF2-40B4-BE49-F238E27FC236}">
+                <a16:creationId xmlns:a16="http://schemas.microsoft.com/office/drawing/2014/main" id="{806F81C2-3092-A5B8-9A75-8BC91C87FFAE}"/>
+              </a:ext>
+            </a:extLst>
+          </p:cNvPr>
+          <p:cNvCxnSpPr>
+            <a:cxnSpLocks/>
+          </p:cNvCxnSpPr>
+          <p:nvPr/>
+        </p:nvCxnSpPr>
+        <p:spPr>
+          <a:xfrm rot="10800000" flipV="1">
+            <a:off x="-1746577" y="5468490"/>
+            <a:ext cx="180000" cy="72000"/>
+          </a:xfrm>
+          <a:prstGeom prst="curvedConnector3">
+            <a:avLst>
+              <a:gd name="adj1" fmla="val 50000"/>
+            </a:avLst>
+          </a:prstGeom>
+          <a:ln>
+            <a:solidFill>
+              <a:srgbClr val="002060"/>
+            </a:solidFill>
+            <a:tailEnd type="triangle"/>
+          </a:ln>
+        </p:spPr>
+        <p:style>
+          <a:lnRef idx="2">
+            <a:schemeClr val="accent1"/>
+          </a:lnRef>
+          <a:fillRef idx="0">
+            <a:schemeClr val="accent1"/>
+          </a:fillRef>
+          <a:effectRef idx="1">
+            <a:schemeClr val="accent1"/>
+          </a:effectRef>
+          <a:fontRef idx="minor">
+            <a:schemeClr val="tx1"/>
+          </a:fontRef>
+        </p:style>
+      </p:cxnSp>
+      <p:sp>
+        <p:nvSpPr>
+          <p:cNvPr id="1093" name="Rectángulo: esquina doblada 1092">
+            <a:extLst>
+              <a:ext uri="{FF2B5EF4-FFF2-40B4-BE49-F238E27FC236}">
+                <a16:creationId xmlns:a16="http://schemas.microsoft.com/office/drawing/2014/main" id="{9779888C-D160-AE21-812F-303B87F7774D}"/>
+              </a:ext>
+            </a:extLst>
+          </p:cNvPr>
+          <p:cNvSpPr/>
+          <p:nvPr/>
+        </p:nvSpPr>
+        <p:spPr>
+          <a:xfrm>
+            <a:off x="-3123289" y="4966008"/>
+            <a:ext cx="1347077" cy="731587"/>
+          </a:xfrm>
+          <a:prstGeom prst="foldedCorner">
+            <a:avLst>
+              <a:gd name="adj" fmla="val 13681"/>
+            </a:avLst>
+          </a:prstGeom>
+          <a:solidFill>
+            <a:srgbClr val="FFE55D"/>
+          </a:solidFill>
+          <a:ln>
+            <a:solidFill>
+              <a:srgbClr val="746100"/>
+            </a:solidFill>
+          </a:ln>
+        </p:spPr>
+        <p:style>
+          <a:lnRef idx="2">
+            <a:schemeClr val="accent1">
+              <a:shade val="15000"/>
+            </a:schemeClr>
+          </a:lnRef>
+          <a:fillRef idx="1">
+            <a:schemeClr val="accent1"/>
+          </a:fillRef>
+          <a:effectRef idx="0">
+            <a:schemeClr val="accent1"/>
+          </a:effectRef>
+          <a:fontRef idx="minor">
+            <a:schemeClr val="lt1"/>
+          </a:fontRef>
+        </p:style>
+        <p:txBody>
+          <a:bodyPr rtlCol="0" anchor="ctr"/>
+          <a:lstStyle/>
+          <a:p>
+            <a:r>
+              <a:rPr lang="es-MX" sz="800" dirty="0">
+                <a:solidFill>
+                  <a:schemeClr val="tx1"/>
+                </a:solidFill>
+              </a:rPr>
+              <a:t>Pensar en un buen </a:t>
+            </a:r>
+            <a:r>
+              <a:rPr lang="es-MX" sz="800" dirty="0" err="1">
+                <a:solidFill>
+                  <a:schemeClr val="tx1"/>
+                </a:solidFill>
+              </a:rPr>
+              <a:t>highlight</a:t>
+            </a:r>
+            <a:r>
+              <a:rPr lang="es-MX" sz="800" dirty="0">
+                <a:solidFill>
+                  <a:schemeClr val="tx1"/>
+                </a:solidFill>
+              </a:rPr>
+              <a:t> para los grupos musculares cuando estén seleccionados (pero iguales para todos)</a:t>
+            </a:r>
+          </a:p>
+        </p:txBody>
+      </p:sp>
+      <p:cxnSp>
+        <p:nvCxnSpPr>
+          <p:cNvPr id="1094" name="Conector: curvado 1093">
+            <a:extLst>
+              <a:ext uri="{FF2B5EF4-FFF2-40B4-BE49-F238E27FC236}">
+                <a16:creationId xmlns:a16="http://schemas.microsoft.com/office/drawing/2014/main" id="{855CA1F2-C6D6-1136-EAE5-2DDC6D4DC9B3}"/>
+              </a:ext>
+            </a:extLst>
+          </p:cNvPr>
+          <p:cNvCxnSpPr>
+            <a:cxnSpLocks/>
+          </p:cNvCxnSpPr>
+          <p:nvPr/>
+        </p:nvCxnSpPr>
+        <p:spPr>
+          <a:xfrm rot="5400000">
+            <a:off x="-569432" y="5654561"/>
+            <a:ext cx="303392" cy="66049"/>
+          </a:xfrm>
+          <a:prstGeom prst="curvedConnector3">
+            <a:avLst>
+              <a:gd name="adj1" fmla="val 50000"/>
+            </a:avLst>
+          </a:prstGeom>
+          <a:ln>
+            <a:solidFill>
+              <a:srgbClr val="002060"/>
+            </a:solidFill>
+            <a:tailEnd type="triangle"/>
+          </a:ln>
+        </p:spPr>
+        <p:style>
+          <a:lnRef idx="2">
+            <a:schemeClr val="accent1"/>
+          </a:lnRef>
+          <a:fillRef idx="0">
+            <a:schemeClr val="accent1"/>
+          </a:fillRef>
+          <a:effectRef idx="1">
+            <a:schemeClr val="accent1"/>
+          </a:effectRef>
+          <a:fontRef idx="minor">
+            <a:schemeClr val="tx1"/>
+          </a:fontRef>
+        </p:style>
+      </p:cxnSp>
+      <p:sp>
+        <p:nvSpPr>
+          <p:cNvPr id="1096" name="Rectángulo: esquina doblada 1095">
+            <a:extLst>
+              <a:ext uri="{FF2B5EF4-FFF2-40B4-BE49-F238E27FC236}">
+                <a16:creationId xmlns:a16="http://schemas.microsoft.com/office/drawing/2014/main" id="{54AAA9F7-3D44-D790-C937-2927629AE6BA}"/>
+              </a:ext>
+            </a:extLst>
+          </p:cNvPr>
+          <p:cNvSpPr/>
+          <p:nvPr/>
+        </p:nvSpPr>
+        <p:spPr>
+          <a:xfrm>
+            <a:off x="-1723194" y="5865383"/>
+            <a:ext cx="1521209" cy="692539"/>
+          </a:xfrm>
+          <a:prstGeom prst="foldedCorner">
+            <a:avLst>
+              <a:gd name="adj" fmla="val 13681"/>
+            </a:avLst>
+          </a:prstGeom>
+          <a:solidFill>
+            <a:srgbClr val="FFE55D"/>
+          </a:solidFill>
+          <a:ln>
+            <a:solidFill>
+              <a:srgbClr val="746100"/>
+            </a:solidFill>
+          </a:ln>
+        </p:spPr>
+        <p:style>
+          <a:lnRef idx="2">
+            <a:schemeClr val="accent1">
+              <a:shade val="15000"/>
+            </a:schemeClr>
+          </a:lnRef>
+          <a:fillRef idx="1">
+            <a:schemeClr val="accent1"/>
+          </a:fillRef>
+          <a:effectRef idx="0">
+            <a:schemeClr val="accent1"/>
+          </a:effectRef>
+          <a:fontRef idx="minor">
+            <a:schemeClr val="lt1"/>
+          </a:fontRef>
+        </p:style>
+        <p:txBody>
+          <a:bodyPr rtlCol="0" anchor="ctr"/>
+          <a:lstStyle/>
+          <a:p>
+            <a:r>
+              <a:rPr lang="es-MX" sz="800" dirty="0" err="1">
+                <a:solidFill>
+                  <a:schemeClr val="tx1"/>
+                </a:solidFill>
+              </a:rPr>
+              <a:t>Popup</a:t>
+            </a:r>
+            <a:r>
+              <a:rPr lang="es-MX" sz="800" dirty="0">
+                <a:solidFill>
+                  <a:schemeClr val="tx1"/>
+                </a:solidFill>
+              </a:rPr>
+              <a:t> de advertencia y confirmación de eliminación. Obligatorio para grupos musculares, </a:t>
+            </a:r>
+            <a:r>
+              <a:rPr lang="es-MX" sz="800" dirty="0" err="1">
+                <a:solidFill>
+                  <a:schemeClr val="tx1"/>
+                </a:solidFill>
+              </a:rPr>
+              <a:t>maybe</a:t>
+            </a:r>
+            <a:r>
+              <a:rPr lang="es-MX" sz="800" dirty="0">
+                <a:solidFill>
+                  <a:schemeClr val="tx1"/>
+                </a:solidFill>
+              </a:rPr>
+              <a:t> para la foto también</a:t>
+            </a:r>
           </a:p>
         </p:txBody>
       </p:sp>

</xml_diff>